<commit_message>
added pdf option in RAI webpage
</commit_message>
<xml_diff>
--- a/assets/TCS349/Unit-1/Lecture6-7_Bias_Detection_Fairness.pptx
+++ b/assets/TCS349/Unit-1/Lecture6-7_Bias_Detection_Fairness.pptx
@@ -5,27 +5,23 @@
     <p:sldMasterId id="2147483648" r:id="rId1"/>
   </p:sldMasterIdLst>
   <p:notesMasterIdLst>
-    <p:notesMasterId r:id="rId20"/>
+    <p:notesMasterId r:id="rId16"/>
   </p:notesMasterIdLst>
   <p:sldIdLst>
     <p:sldId id="256" r:id="rId2"/>
-    <p:sldId id="257" r:id="rId3"/>
-    <p:sldId id="258" r:id="rId4"/>
-    <p:sldId id="259" r:id="rId5"/>
-    <p:sldId id="260" r:id="rId6"/>
-    <p:sldId id="261" r:id="rId7"/>
-    <p:sldId id="262" r:id="rId8"/>
-    <p:sldId id="263" r:id="rId9"/>
-    <p:sldId id="264" r:id="rId10"/>
-    <p:sldId id="265" r:id="rId11"/>
-    <p:sldId id="266" r:id="rId12"/>
-    <p:sldId id="267" r:id="rId13"/>
-    <p:sldId id="268" r:id="rId14"/>
-    <p:sldId id="269" r:id="rId15"/>
-    <p:sldId id="270" r:id="rId16"/>
-    <p:sldId id="271" r:id="rId17"/>
-    <p:sldId id="272" r:id="rId18"/>
-    <p:sldId id="273" r:id="rId19"/>
+    <p:sldId id="259" r:id="rId3"/>
+    <p:sldId id="260" r:id="rId4"/>
+    <p:sldId id="261" r:id="rId5"/>
+    <p:sldId id="262" r:id="rId6"/>
+    <p:sldId id="263" r:id="rId7"/>
+    <p:sldId id="264" r:id="rId8"/>
+    <p:sldId id="265" r:id="rId9"/>
+    <p:sldId id="266" r:id="rId10"/>
+    <p:sldId id="267" r:id="rId11"/>
+    <p:sldId id="268" r:id="rId12"/>
+    <p:sldId id="269" r:id="rId13"/>
+    <p:sldId id="270" r:id="rId14"/>
+    <p:sldId id="273" r:id="rId15"/>
   </p:sldIdLst>
   <p:sldSz cx="12192000" cy="6858000"/>
   <p:notesSz cx="6858000" cy="12192000"/>
@@ -1007,342 +1003,6 @@
 </p:notes>
 </file>
 
-<file path=ppt/notesSlides/notesSlide15.xml><?xml version="1.0" encoding="utf-8"?>
-<p:notes xmlns:a="http://schemas.openxmlformats.org/drawingml/2006/main" xmlns:r="http://schemas.openxmlformats.org/officeDocument/2006/relationships" xmlns:p="http://schemas.openxmlformats.org/presentationml/2006/main">
-  <p:cSld>
-    <p:spTree>
-      <p:nvGrpSpPr>
-        <p:cNvPr id="1" name=""/>
-        <p:cNvGrpSpPr/>
-        <p:nvPr/>
-      </p:nvGrpSpPr>
-      <p:grpSpPr>
-        <a:xfrm>
-          <a:off x="0" y="0"/>
-          <a:ext cx="0" cy="0"/>
-          <a:chOff x="0" y="0"/>
-          <a:chExt cx="0" cy="0"/>
-        </a:xfrm>
-      </p:grpSpPr>
-      <p:sp>
-        <p:nvSpPr>
-          <p:cNvPr id="2" name="Slide Image Placeholder 1"/>
-          <p:cNvSpPr>
-            <a:spLocks noGrp="1" noRot="1" noChangeAspect="1"/>
-          </p:cNvSpPr>
-          <p:nvPr>
-            <p:ph type="sldImg"/>
-          </p:nvPr>
-        </p:nvSpPr>
-        <p:spPr/>
-      </p:sp>
-      <p:sp>
-        <p:nvSpPr>
-          <p:cNvPr id="3" name="Notes Placeholder 2"/>
-          <p:cNvSpPr>
-            <a:spLocks noGrp="1"/>
-          </p:cNvSpPr>
-          <p:nvPr>
-            <p:ph type="body" idx="1"/>
-          </p:nvPr>
-        </p:nvSpPr>
-        <p:spPr/>
-        <p:txBody>
-          <a:bodyPr/>
-          <a:lstStyle/>
-          <a:p>
-            <a:endParaRPr lang="en-US" dirty="0"/>
-          </a:p>
-        </p:txBody>
-      </p:sp>
-      <p:sp>
-        <p:nvSpPr>
-          <p:cNvPr id="4" name="Slide Number Placeholder 3"/>
-          <p:cNvSpPr>
-            <a:spLocks noGrp="1"/>
-          </p:cNvSpPr>
-          <p:nvPr>
-            <p:ph type="sldNum" sz="quarter" idx="10"/>
-          </p:nvPr>
-        </p:nvSpPr>
-        <p:spPr/>
-        <p:txBody>
-          <a:bodyPr/>
-          <a:lstStyle/>
-          <a:p>
-            <a:fld id="{F7021451-1387-4CA6-816F-3879F97B5CBC}" type="slidenum">
-              <a:rPr lang="en-US"/>
-              <a:t>15</a:t>
-            </a:fld>
-            <a:endParaRPr lang="en-US"/>
-          </a:p>
-        </p:txBody>
-      </p:sp>
-    </p:spTree>
-    <p:extLst>
-      <p:ext uri="{BB962C8B-B14F-4D97-AF65-F5344CB8AC3E}">
-        <p14:creationId xmlns:p14="http://schemas.microsoft.com/office/powerpoint/2010/main" val="1024086991"/>
-      </p:ext>
-    </p:extLst>
-  </p:cSld>
-  <p:clrMapOvr>
-    <a:masterClrMapping/>
-  </p:clrMapOvr>
-</p:notes>
-</file>
-
-<file path=ppt/notesSlides/notesSlide16.xml><?xml version="1.0" encoding="utf-8"?>
-<p:notes xmlns:a="http://schemas.openxmlformats.org/drawingml/2006/main" xmlns:r="http://schemas.openxmlformats.org/officeDocument/2006/relationships" xmlns:p="http://schemas.openxmlformats.org/presentationml/2006/main">
-  <p:cSld>
-    <p:spTree>
-      <p:nvGrpSpPr>
-        <p:cNvPr id="1" name=""/>
-        <p:cNvGrpSpPr/>
-        <p:nvPr/>
-      </p:nvGrpSpPr>
-      <p:grpSpPr>
-        <a:xfrm>
-          <a:off x="0" y="0"/>
-          <a:ext cx="0" cy="0"/>
-          <a:chOff x="0" y="0"/>
-          <a:chExt cx="0" cy="0"/>
-        </a:xfrm>
-      </p:grpSpPr>
-      <p:sp>
-        <p:nvSpPr>
-          <p:cNvPr id="2" name="Slide Image Placeholder 1"/>
-          <p:cNvSpPr>
-            <a:spLocks noGrp="1" noRot="1" noChangeAspect="1"/>
-          </p:cNvSpPr>
-          <p:nvPr>
-            <p:ph type="sldImg"/>
-          </p:nvPr>
-        </p:nvSpPr>
-        <p:spPr/>
-      </p:sp>
-      <p:sp>
-        <p:nvSpPr>
-          <p:cNvPr id="3" name="Notes Placeholder 2"/>
-          <p:cNvSpPr>
-            <a:spLocks noGrp="1"/>
-          </p:cNvSpPr>
-          <p:nvPr>
-            <p:ph type="body" idx="1"/>
-          </p:nvPr>
-        </p:nvSpPr>
-        <p:spPr/>
-        <p:txBody>
-          <a:bodyPr/>
-          <a:lstStyle/>
-          <a:p>
-            <a:endParaRPr lang="en-US" dirty="0"/>
-          </a:p>
-        </p:txBody>
-      </p:sp>
-      <p:sp>
-        <p:nvSpPr>
-          <p:cNvPr id="4" name="Slide Number Placeholder 3"/>
-          <p:cNvSpPr>
-            <a:spLocks noGrp="1"/>
-          </p:cNvSpPr>
-          <p:nvPr>
-            <p:ph type="sldNum" sz="quarter" idx="10"/>
-          </p:nvPr>
-        </p:nvSpPr>
-        <p:spPr/>
-        <p:txBody>
-          <a:bodyPr/>
-          <a:lstStyle/>
-          <a:p>
-            <a:fld id="{F7021451-1387-4CA6-816F-3879F97B5CBC}" type="slidenum">
-              <a:rPr lang="en-US"/>
-              <a:t>16</a:t>
-            </a:fld>
-            <a:endParaRPr lang="en-US"/>
-          </a:p>
-        </p:txBody>
-      </p:sp>
-    </p:spTree>
-    <p:extLst>
-      <p:ext uri="{BB962C8B-B14F-4D97-AF65-F5344CB8AC3E}">
-        <p14:creationId xmlns:p14="http://schemas.microsoft.com/office/powerpoint/2010/main" val="1024086991"/>
-      </p:ext>
-    </p:extLst>
-  </p:cSld>
-  <p:clrMapOvr>
-    <a:masterClrMapping/>
-  </p:clrMapOvr>
-</p:notes>
-</file>
-
-<file path=ppt/notesSlides/notesSlide17.xml><?xml version="1.0" encoding="utf-8"?>
-<p:notes xmlns:a="http://schemas.openxmlformats.org/drawingml/2006/main" xmlns:r="http://schemas.openxmlformats.org/officeDocument/2006/relationships" xmlns:p="http://schemas.openxmlformats.org/presentationml/2006/main">
-  <p:cSld>
-    <p:spTree>
-      <p:nvGrpSpPr>
-        <p:cNvPr id="1" name=""/>
-        <p:cNvGrpSpPr/>
-        <p:nvPr/>
-      </p:nvGrpSpPr>
-      <p:grpSpPr>
-        <a:xfrm>
-          <a:off x="0" y="0"/>
-          <a:ext cx="0" cy="0"/>
-          <a:chOff x="0" y="0"/>
-          <a:chExt cx="0" cy="0"/>
-        </a:xfrm>
-      </p:grpSpPr>
-      <p:sp>
-        <p:nvSpPr>
-          <p:cNvPr id="2" name="Slide Image Placeholder 1"/>
-          <p:cNvSpPr>
-            <a:spLocks noGrp="1" noRot="1" noChangeAspect="1"/>
-          </p:cNvSpPr>
-          <p:nvPr>
-            <p:ph type="sldImg"/>
-          </p:nvPr>
-        </p:nvSpPr>
-        <p:spPr/>
-      </p:sp>
-      <p:sp>
-        <p:nvSpPr>
-          <p:cNvPr id="3" name="Notes Placeholder 2"/>
-          <p:cNvSpPr>
-            <a:spLocks noGrp="1"/>
-          </p:cNvSpPr>
-          <p:nvPr>
-            <p:ph type="body" idx="1"/>
-          </p:nvPr>
-        </p:nvSpPr>
-        <p:spPr/>
-        <p:txBody>
-          <a:bodyPr/>
-          <a:lstStyle/>
-          <a:p>
-            <a:endParaRPr lang="en-US" dirty="0"/>
-          </a:p>
-        </p:txBody>
-      </p:sp>
-      <p:sp>
-        <p:nvSpPr>
-          <p:cNvPr id="4" name="Slide Number Placeholder 3"/>
-          <p:cNvSpPr>
-            <a:spLocks noGrp="1"/>
-          </p:cNvSpPr>
-          <p:nvPr>
-            <p:ph type="sldNum" sz="quarter" idx="10"/>
-          </p:nvPr>
-        </p:nvSpPr>
-        <p:spPr/>
-        <p:txBody>
-          <a:bodyPr/>
-          <a:lstStyle/>
-          <a:p>
-            <a:fld id="{F7021451-1387-4CA6-816F-3879F97B5CBC}" type="slidenum">
-              <a:rPr lang="en-US"/>
-              <a:t>17</a:t>
-            </a:fld>
-            <a:endParaRPr lang="en-US"/>
-          </a:p>
-        </p:txBody>
-      </p:sp>
-    </p:spTree>
-    <p:extLst>
-      <p:ext uri="{BB962C8B-B14F-4D97-AF65-F5344CB8AC3E}">
-        <p14:creationId xmlns:p14="http://schemas.microsoft.com/office/powerpoint/2010/main" val="1024086991"/>
-      </p:ext>
-    </p:extLst>
-  </p:cSld>
-  <p:clrMapOvr>
-    <a:masterClrMapping/>
-  </p:clrMapOvr>
-</p:notes>
-</file>
-
-<file path=ppt/notesSlides/notesSlide18.xml><?xml version="1.0" encoding="utf-8"?>
-<p:notes xmlns:a="http://schemas.openxmlformats.org/drawingml/2006/main" xmlns:r="http://schemas.openxmlformats.org/officeDocument/2006/relationships" xmlns:p="http://schemas.openxmlformats.org/presentationml/2006/main">
-  <p:cSld>
-    <p:spTree>
-      <p:nvGrpSpPr>
-        <p:cNvPr id="1" name=""/>
-        <p:cNvGrpSpPr/>
-        <p:nvPr/>
-      </p:nvGrpSpPr>
-      <p:grpSpPr>
-        <a:xfrm>
-          <a:off x="0" y="0"/>
-          <a:ext cx="0" cy="0"/>
-          <a:chOff x="0" y="0"/>
-          <a:chExt cx="0" cy="0"/>
-        </a:xfrm>
-      </p:grpSpPr>
-      <p:sp>
-        <p:nvSpPr>
-          <p:cNvPr id="2" name="Slide Image Placeholder 1"/>
-          <p:cNvSpPr>
-            <a:spLocks noGrp="1" noRot="1" noChangeAspect="1"/>
-          </p:cNvSpPr>
-          <p:nvPr>
-            <p:ph type="sldImg"/>
-          </p:nvPr>
-        </p:nvSpPr>
-        <p:spPr/>
-      </p:sp>
-      <p:sp>
-        <p:nvSpPr>
-          <p:cNvPr id="3" name="Notes Placeholder 2"/>
-          <p:cNvSpPr>
-            <a:spLocks noGrp="1"/>
-          </p:cNvSpPr>
-          <p:nvPr>
-            <p:ph type="body" idx="1"/>
-          </p:nvPr>
-        </p:nvSpPr>
-        <p:spPr/>
-        <p:txBody>
-          <a:bodyPr/>
-          <a:lstStyle/>
-          <a:p>
-            <a:endParaRPr lang="en-US" dirty="0"/>
-          </a:p>
-        </p:txBody>
-      </p:sp>
-      <p:sp>
-        <p:nvSpPr>
-          <p:cNvPr id="4" name="Slide Number Placeholder 3"/>
-          <p:cNvSpPr>
-            <a:spLocks noGrp="1"/>
-          </p:cNvSpPr>
-          <p:nvPr>
-            <p:ph type="sldNum" sz="quarter" idx="10"/>
-          </p:nvPr>
-        </p:nvSpPr>
-        <p:spPr/>
-        <p:txBody>
-          <a:bodyPr/>
-          <a:lstStyle/>
-          <a:p>
-            <a:fld id="{F7021451-1387-4CA6-816F-3879F97B5CBC}" type="slidenum">
-              <a:rPr lang="en-US"/>
-              <a:t>18</a:t>
-            </a:fld>
-            <a:endParaRPr lang="en-US"/>
-          </a:p>
-        </p:txBody>
-      </p:sp>
-    </p:spTree>
-    <p:extLst>
-      <p:ext uri="{BB962C8B-B14F-4D97-AF65-F5344CB8AC3E}">
-        <p14:creationId xmlns:p14="http://schemas.microsoft.com/office/powerpoint/2010/main" val="1024086991"/>
-      </p:ext>
-    </p:extLst>
-  </p:cSld>
-  <p:clrMapOvr>
-    <a:masterClrMapping/>
-  </p:clrMapOvr>
-</p:notes>
-</file>
-
 <file path=ppt/notesSlides/notesSlide2.xml><?xml version="1.0" encoding="utf-8"?>
 <p:notes xmlns:a="http://schemas.openxmlformats.org/drawingml/2006/main" xmlns:r="http://schemas.openxmlformats.org/officeDocument/2006/relationships" xmlns:p="http://schemas.openxmlformats.org/presentationml/2006/main">
   <p:cSld>
@@ -2614,6 +2274,17 @@
               <a:buNone/>
             </a:pPr>
             <a:r>
+              <a:rPr lang="en-US" dirty="0">
+                <a:solidFill>
+                  <a:srgbClr val="191919"/>
+                </a:solidFill>
+                <a:latin typeface="Times New Roman" pitchFamily="34" charset="0"/>
+                <a:ea typeface="Times New Roman" pitchFamily="34" charset="-122"/>
+                <a:cs typeface="Times New Roman" pitchFamily="34" charset="-120"/>
+              </a:rPr>
+              <a:t>M</a:t>
+            </a:r>
+            <a:r>
               <a:rPr lang="en-US" sz="1800" dirty="0">
                 <a:solidFill>
                   <a:srgbClr val="191919"/>
@@ -2622,7 +2293,7 @@
                 <a:ea typeface="Times New Roman" pitchFamily="34" charset="-122"/>
                 <a:cs typeface="Times New Roman" pitchFamily="34" charset="-120"/>
               </a:rPr>
-              <a:t>Dr. Manoj Kaushik</a:t>
+              <a:t>r. Manoj Kaushik</a:t>
             </a:r>
             <a:endParaRPr lang="en-US" sz="1800" dirty="0"/>
           </a:p>
@@ -3052,45 +2723,6 @@
       </p:sp>
       <p:sp>
         <p:nvSpPr>
-          <p:cNvPr id="21" name="Text 15"/>
-          <p:cNvSpPr/>
-          <p:nvPr/>
-        </p:nvSpPr>
-        <p:spPr>
-          <a:xfrm>
-            <a:off x="502920" y="5989320"/>
-            <a:ext cx="10744200" cy="411480"/>
-          </a:xfrm>
-          <a:prstGeom prst="rect">
-            <a:avLst/>
-          </a:prstGeom>
-          <a:noFill/>
-          <a:ln/>
-        </p:spPr>
-        <p:txBody>
-          <a:bodyPr wrap="square" lIns="0" tIns="0" rIns="0" bIns="0" rtlCol="0" anchor="ctr"/>
-          <a:lstStyle/>
-          <a:p>
-            <a:pPr marL="0" indent="0">
-              <a:buNone/>
-            </a:pPr>
-            <a:r>
-              <a:rPr lang="en-US" sz="1200" i="1" dirty="0">
-                <a:solidFill>
-                  <a:srgbClr val="595959"/>
-                </a:solidFill>
-                <a:latin typeface="Times New Roman" pitchFamily="34" charset="0"/>
-                <a:ea typeface="Times New Roman" pitchFamily="34" charset="-122"/>
-                <a:cs typeface="Times New Roman" pitchFamily="34" charset="-120"/>
-              </a:rPr>
-              <a:t>Teaching cue: This combined session bridges bias detection (Lecture 6) with fairness theory (Lecture 7) in the approved Unit I sequence.</a:t>
-            </a:r>
-            <a:endParaRPr lang="en-US" sz="1200" dirty="0"/>
-          </a:p>
-        </p:txBody>
-      </p:sp>
-      <p:sp>
-        <p:nvSpPr>
           <p:cNvPr id="22" name="Text 16"/>
           <p:cNvSpPr/>
           <p:nvPr/>
@@ -3137,806 +2769,6 @@
 </file>
 
 <file path=ppt/slides/slide10.xml><?xml version="1.0" encoding="utf-8"?>
-<p:sld xmlns:a="http://schemas.openxmlformats.org/drawingml/2006/main" xmlns:r="http://schemas.openxmlformats.org/officeDocument/2006/relationships" xmlns:p="http://schemas.openxmlformats.org/presentationml/2006/main">
-  <p:cSld name="Slide 10">
-    <p:bg>
-      <p:bgPr>
-        <a:solidFill>
-          <a:srgbClr val="FFFFFF"/>
-        </a:solidFill>
-        <a:effectLst/>
-      </p:bgPr>
-    </p:bg>
-    <p:spTree>
-      <p:nvGrpSpPr>
-        <p:cNvPr id="1" name=""/>
-        <p:cNvGrpSpPr/>
-        <p:nvPr/>
-      </p:nvGrpSpPr>
-      <p:grpSpPr>
-        <a:xfrm>
-          <a:off x="0" y="0"/>
-          <a:ext cx="0" cy="0"/>
-          <a:chOff x="0" y="0"/>
-          <a:chExt cx="0" cy="0"/>
-        </a:xfrm>
-      </p:grpSpPr>
-      <p:sp>
-        <p:nvSpPr>
-          <p:cNvPr id="2" name="Shape 0"/>
-          <p:cNvSpPr/>
-          <p:nvPr/>
-        </p:nvSpPr>
-        <p:spPr>
-          <a:xfrm>
-            <a:off x="0" y="0"/>
-            <a:ext cx="12191695" cy="502920"/>
-          </a:xfrm>
-          <a:prstGeom prst="rect">
-            <a:avLst/>
-          </a:prstGeom>
-          <a:solidFill>
-            <a:srgbClr val="F8FBFF"/>
-          </a:solidFill>
-          <a:ln w="12700">
-            <a:solidFill>
-              <a:srgbClr val="F8FBFF"/>
-            </a:solidFill>
-            <a:prstDash val="solid"/>
-          </a:ln>
-        </p:spPr>
-        <p:txBody>
-          <a:bodyPr/>
-          <a:lstStyle/>
-          <a:p>
-            <a:endParaRPr lang="en-IN"/>
-          </a:p>
-        </p:txBody>
-      </p:sp>
-      <p:sp>
-        <p:nvSpPr>
-          <p:cNvPr id="3" name="Shape 1"/>
-          <p:cNvSpPr/>
-          <p:nvPr/>
-        </p:nvSpPr>
-        <p:spPr>
-          <a:xfrm>
-            <a:off x="0" y="475488"/>
-            <a:ext cx="12191695" cy="27432"/>
-          </a:xfrm>
-          <a:prstGeom prst="rect">
-            <a:avLst/>
-          </a:prstGeom>
-          <a:solidFill>
-            <a:srgbClr val="2E75B6"/>
-          </a:solidFill>
-          <a:ln w="12700">
-            <a:solidFill>
-              <a:srgbClr val="2E75B6"/>
-            </a:solidFill>
-            <a:prstDash val="solid"/>
-          </a:ln>
-        </p:spPr>
-        <p:txBody>
-          <a:bodyPr/>
-          <a:lstStyle/>
-          <a:p>
-            <a:endParaRPr lang="en-IN"/>
-          </a:p>
-        </p:txBody>
-      </p:sp>
-      <p:sp>
-        <p:nvSpPr>
-          <p:cNvPr id="4" name="Text 2"/>
-          <p:cNvSpPr/>
-          <p:nvPr/>
-        </p:nvSpPr>
-        <p:spPr>
-          <a:xfrm>
-            <a:off x="365760" y="73152"/>
-            <a:ext cx="6400800" cy="274320"/>
-          </a:xfrm>
-          <a:prstGeom prst="rect">
-            <a:avLst/>
-          </a:prstGeom>
-          <a:noFill/>
-          <a:ln/>
-        </p:spPr>
-        <p:txBody>
-          <a:bodyPr wrap="square" lIns="0" tIns="0" rIns="0" bIns="0" rtlCol="0" anchor="ctr"/>
-          <a:lstStyle/>
-          <a:p>
-            <a:pPr marL="0" indent="0">
-              <a:buNone/>
-            </a:pPr>
-            <a:r>
-              <a:rPr lang="en-US" sz="1800" b="1" dirty="0">
-                <a:solidFill>
-                  <a:srgbClr val="1F4E79"/>
-                </a:solidFill>
-                <a:latin typeface="Times New Roman" pitchFamily="34" charset="0"/>
-                <a:ea typeface="Times New Roman" pitchFamily="34" charset="-122"/>
-                <a:cs typeface="Times New Roman" pitchFamily="34" charset="-120"/>
-              </a:rPr>
-              <a:t>TCS349: Responsible and Explainable AI</a:t>
-            </a:r>
-            <a:endParaRPr lang="en-US" sz="1800" dirty="0"/>
-          </a:p>
-        </p:txBody>
-      </p:sp>
-      <p:sp>
-        <p:nvSpPr>
-          <p:cNvPr id="5" name="Text 3"/>
-          <p:cNvSpPr/>
-          <p:nvPr/>
-        </p:nvSpPr>
-        <p:spPr>
-          <a:xfrm>
-            <a:off x="8503920" y="82296"/>
-            <a:ext cx="3200400" cy="274320"/>
-          </a:xfrm>
-          <a:prstGeom prst="rect">
-            <a:avLst/>
-          </a:prstGeom>
-          <a:noFill/>
-          <a:ln/>
-        </p:spPr>
-        <p:txBody>
-          <a:bodyPr wrap="square" lIns="0" tIns="0" rIns="0" bIns="0" rtlCol="0" anchor="ctr"/>
-          <a:lstStyle/>
-          <a:p>
-            <a:pPr marL="0" indent="0" algn="r">
-              <a:buNone/>
-            </a:pPr>
-            <a:r>
-              <a:rPr lang="en-US" sz="1600" b="1" dirty="0">
-                <a:solidFill>
-                  <a:srgbClr val="1F4E79"/>
-                </a:solidFill>
-                <a:latin typeface="Times New Roman" pitchFamily="34" charset="0"/>
-                <a:ea typeface="Times New Roman" pitchFamily="34" charset="-122"/>
-                <a:cs typeface="Times New Roman" pitchFamily="34" charset="-120"/>
-              </a:rPr>
-              <a:t>Unit 1 | Lecture 6</a:t>
-            </a:r>
-            <a:endParaRPr lang="en-US" sz="1600" dirty="0"/>
-          </a:p>
-        </p:txBody>
-      </p:sp>
-      <p:sp>
-        <p:nvSpPr>
-          <p:cNvPr id="6" name="Text 4"/>
-          <p:cNvSpPr/>
-          <p:nvPr/>
-        </p:nvSpPr>
-        <p:spPr>
-          <a:xfrm>
-            <a:off x="502920" y="658368"/>
-            <a:ext cx="11155680" cy="640080"/>
-          </a:xfrm>
-          <a:prstGeom prst="rect">
-            <a:avLst/>
-          </a:prstGeom>
-          <a:noFill/>
-          <a:ln/>
-        </p:spPr>
-        <p:txBody>
-          <a:bodyPr wrap="square" lIns="0" tIns="0" rIns="0" bIns="0" rtlCol="0" anchor="ctr"/>
-          <a:lstStyle/>
-          <a:p>
-            <a:pPr marL="0" indent="0">
-              <a:buNone/>
-            </a:pPr>
-            <a:r>
-              <a:rPr lang="en-US" sz="2400" b="1" dirty="0">
-                <a:solidFill>
-                  <a:srgbClr val="1F4E79"/>
-                </a:solidFill>
-                <a:latin typeface="Times New Roman" pitchFamily="34" charset="0"/>
-                <a:ea typeface="Times New Roman" pitchFamily="34" charset="-122"/>
-                <a:cs typeface="Times New Roman" pitchFamily="34" charset="-120"/>
-              </a:rPr>
-              <a:t>7. Tools for Bias Detection</a:t>
-            </a:r>
-            <a:endParaRPr lang="en-US" sz="2400" dirty="0"/>
-          </a:p>
-        </p:txBody>
-      </p:sp>
-      <p:sp>
-        <p:nvSpPr>
-          <p:cNvPr id="7" name="Text 5"/>
-          <p:cNvSpPr/>
-          <p:nvPr/>
-        </p:nvSpPr>
-        <p:spPr>
-          <a:xfrm>
-            <a:off x="594360" y="1463040"/>
-            <a:ext cx="10972800" cy="4206240"/>
-          </a:xfrm>
-          <a:prstGeom prst="rect">
-            <a:avLst/>
-          </a:prstGeom>
-          <a:noFill/>
-          <a:ln/>
-        </p:spPr>
-        <p:txBody>
-          <a:bodyPr wrap="square" lIns="50800" tIns="50800" rIns="50800" bIns="50800" rtlCol="0" anchor="ctr"/>
-          <a:lstStyle/>
-          <a:p>
-            <a:pPr marL="0" indent="0">
-              <a:buNone/>
-            </a:pPr>
-            <a:r>
-              <a:rPr lang="en-US" sz="1800" dirty="0">
-                <a:solidFill>
-                  <a:srgbClr val="191919"/>
-                </a:solidFill>
-                <a:latin typeface="Times New Roman" pitchFamily="34" charset="0"/>
-                <a:ea typeface="Times New Roman" pitchFamily="34" charset="-122"/>
-                <a:cs typeface="Times New Roman" pitchFamily="34" charset="-120"/>
-              </a:rPr>
-              <a:t>Fairlearn (Microsoft): a Python library for assessing and mitigating fairness issues in ML models.</a:t>
-            </a:r>
-            <a:endParaRPr lang="en-US" sz="1800" dirty="0"/>
-          </a:p>
-          <a:p>
-            <a:pPr marL="0" indent="0">
-              <a:buNone/>
-            </a:pPr>
-            <a:endParaRPr lang="en-US" sz="1800" dirty="0"/>
-          </a:p>
-          <a:p>
-            <a:pPr marL="0" indent="0">
-              <a:buNone/>
-            </a:pPr>
-            <a:r>
-              <a:rPr lang="en-US" sz="1800" dirty="0">
-                <a:solidFill>
-                  <a:srgbClr val="191919"/>
-                </a:solidFill>
-                <a:latin typeface="Times New Roman" pitchFamily="34" charset="0"/>
-                <a:ea typeface="Times New Roman" pitchFamily="34" charset="-122"/>
-                <a:cs typeface="Times New Roman" pitchFamily="34" charset="-120"/>
-              </a:rPr>
-              <a:t>IBM AI Fairness 360 (AIF360): an open-source toolkit offering 70+ fairness metrics and bias-mitigation algorithms.</a:t>
-            </a:r>
-            <a:endParaRPr lang="en-US" sz="1800" dirty="0"/>
-          </a:p>
-          <a:p>
-            <a:pPr marL="0" indent="0">
-              <a:buNone/>
-            </a:pPr>
-            <a:endParaRPr lang="en-US" sz="1800" dirty="0"/>
-          </a:p>
-          <a:p>
-            <a:pPr marL="0" indent="0">
-              <a:buNone/>
-            </a:pPr>
-            <a:r>
-              <a:rPr lang="en-US" sz="1800" dirty="0">
-                <a:solidFill>
-                  <a:srgbClr val="191919"/>
-                </a:solidFill>
-                <a:latin typeface="Times New Roman" pitchFamily="34" charset="0"/>
-                <a:ea typeface="Times New Roman" pitchFamily="34" charset="-122"/>
-                <a:cs typeface="Times New Roman" pitchFamily="34" charset="-120"/>
-              </a:rPr>
-              <a:t>Aequitas: an audit toolkit that generates subgroup-wise bias reports directly from model predictions.</a:t>
-            </a:r>
-            <a:endParaRPr lang="en-US" sz="1800" dirty="0"/>
-          </a:p>
-          <a:p>
-            <a:pPr marL="0" indent="0">
-              <a:buNone/>
-            </a:pPr>
-            <a:endParaRPr lang="en-US" sz="1800" dirty="0"/>
-          </a:p>
-          <a:p>
-            <a:pPr marL="0" indent="0">
-              <a:buNone/>
-            </a:pPr>
-            <a:r>
-              <a:rPr lang="en-US" sz="1800" dirty="0">
-                <a:solidFill>
-                  <a:srgbClr val="191919"/>
-                </a:solidFill>
-                <a:latin typeface="Times New Roman" pitchFamily="34" charset="0"/>
-                <a:ea typeface="Times New Roman" pitchFamily="34" charset="-122"/>
-                <a:cs typeface="Times New Roman" pitchFamily="34" charset="-120"/>
-              </a:rPr>
-              <a:t>These tools automate the same subgroup and confusion-matrix analysis performed manually in this lecture.</a:t>
-            </a:r>
-            <a:endParaRPr lang="en-US" sz="1800" dirty="0"/>
-          </a:p>
-        </p:txBody>
-      </p:sp>
-      <p:sp>
-        <p:nvSpPr>
-          <p:cNvPr id="8" name="Text 6"/>
-          <p:cNvSpPr/>
-          <p:nvPr/>
-        </p:nvSpPr>
-        <p:spPr>
-          <a:xfrm>
-            <a:off x="502920" y="5989320"/>
-            <a:ext cx="10744200" cy="411480"/>
-          </a:xfrm>
-          <a:prstGeom prst="rect">
-            <a:avLst/>
-          </a:prstGeom>
-          <a:noFill/>
-          <a:ln/>
-        </p:spPr>
-        <p:txBody>
-          <a:bodyPr wrap="square" lIns="0" tIns="0" rIns="0" bIns="0" rtlCol="0" anchor="ctr"/>
-          <a:lstStyle/>
-          <a:p>
-            <a:pPr marL="0" indent="0">
-              <a:buNone/>
-            </a:pPr>
-            <a:r>
-              <a:rPr lang="en-US" sz="1200" i="1" dirty="0">
-                <a:solidFill>
-                  <a:srgbClr val="595959"/>
-                </a:solidFill>
-                <a:latin typeface="Times New Roman" pitchFamily="34" charset="0"/>
-                <a:ea typeface="Times New Roman" pitchFamily="34" charset="-122"/>
-                <a:cs typeface="Times New Roman" pitchFamily="34" charset="-120"/>
-              </a:rPr>
-              <a:t>Teaching cue: Mention that these tools resurface in the Unit IV self-learning assignment alongside LIME and SHAP.</a:t>
-            </a:r>
-            <a:endParaRPr lang="en-US" sz="1200" dirty="0"/>
-          </a:p>
-        </p:txBody>
-      </p:sp>
-      <p:sp>
-        <p:nvSpPr>
-          <p:cNvPr id="9" name="Text 7"/>
-          <p:cNvSpPr/>
-          <p:nvPr/>
-        </p:nvSpPr>
-        <p:spPr>
-          <a:xfrm>
-            <a:off x="11430000" y="6446520"/>
-            <a:ext cx="365760" cy="182880"/>
-          </a:xfrm>
-          <a:prstGeom prst="rect">
-            <a:avLst/>
-          </a:prstGeom>
-          <a:noFill/>
-          <a:ln/>
-        </p:spPr>
-        <p:txBody>
-          <a:bodyPr wrap="square" lIns="0" tIns="0" rIns="0" bIns="0" rtlCol="0" anchor="ctr"/>
-          <a:lstStyle/>
-          <a:p>
-            <a:pPr marL="0" indent="0" algn="ctr">
-              <a:buNone/>
-            </a:pPr>
-            <a:r>
-              <a:rPr lang="en-US" sz="1200" dirty="0">
-                <a:solidFill>
-                  <a:srgbClr val="595959"/>
-                </a:solidFill>
-                <a:latin typeface="Times New Roman" pitchFamily="34" charset="0"/>
-                <a:ea typeface="Times New Roman" pitchFamily="34" charset="-122"/>
-                <a:cs typeface="Times New Roman" pitchFamily="34" charset="-120"/>
-              </a:rPr>
-              <a:t>10</a:t>
-            </a:r>
-            <a:endParaRPr lang="en-US" sz="1200" dirty="0"/>
-          </a:p>
-        </p:txBody>
-      </p:sp>
-    </p:spTree>
-  </p:cSld>
-  <p:clrMapOvr>
-    <a:masterClrMapping/>
-  </p:clrMapOvr>
-</p:sld>
-</file>
-
-<file path=ppt/slides/slide11.xml><?xml version="1.0" encoding="utf-8"?>
-<p:sld xmlns:a="http://schemas.openxmlformats.org/drawingml/2006/main" xmlns:r="http://schemas.openxmlformats.org/officeDocument/2006/relationships" xmlns:p="http://schemas.openxmlformats.org/presentationml/2006/main">
-  <p:cSld name="Slide 11">
-    <p:bg>
-      <p:bgPr>
-        <a:solidFill>
-          <a:srgbClr val="FFFFFF"/>
-        </a:solidFill>
-        <a:effectLst/>
-      </p:bgPr>
-    </p:bg>
-    <p:spTree>
-      <p:nvGrpSpPr>
-        <p:cNvPr id="1" name=""/>
-        <p:cNvGrpSpPr/>
-        <p:nvPr/>
-      </p:nvGrpSpPr>
-      <p:grpSpPr>
-        <a:xfrm>
-          <a:off x="0" y="0"/>
-          <a:ext cx="0" cy="0"/>
-          <a:chOff x="0" y="0"/>
-          <a:chExt cx="0" cy="0"/>
-        </a:xfrm>
-      </p:grpSpPr>
-      <p:sp>
-        <p:nvSpPr>
-          <p:cNvPr id="2" name="Shape 0"/>
-          <p:cNvSpPr/>
-          <p:nvPr/>
-        </p:nvSpPr>
-        <p:spPr>
-          <a:xfrm>
-            <a:off x="0" y="0"/>
-            <a:ext cx="12191695" cy="502920"/>
-          </a:xfrm>
-          <a:prstGeom prst="rect">
-            <a:avLst/>
-          </a:prstGeom>
-          <a:solidFill>
-            <a:srgbClr val="F8FBFF"/>
-          </a:solidFill>
-          <a:ln w="12700">
-            <a:solidFill>
-              <a:srgbClr val="F8FBFF"/>
-            </a:solidFill>
-            <a:prstDash val="solid"/>
-          </a:ln>
-        </p:spPr>
-        <p:txBody>
-          <a:bodyPr/>
-          <a:lstStyle/>
-          <a:p>
-            <a:endParaRPr lang="en-IN"/>
-          </a:p>
-        </p:txBody>
-      </p:sp>
-      <p:sp>
-        <p:nvSpPr>
-          <p:cNvPr id="3" name="Shape 1"/>
-          <p:cNvSpPr/>
-          <p:nvPr/>
-        </p:nvSpPr>
-        <p:spPr>
-          <a:xfrm>
-            <a:off x="0" y="475488"/>
-            <a:ext cx="12191695" cy="27432"/>
-          </a:xfrm>
-          <a:prstGeom prst="rect">
-            <a:avLst/>
-          </a:prstGeom>
-          <a:solidFill>
-            <a:srgbClr val="2E75B6"/>
-          </a:solidFill>
-          <a:ln w="12700">
-            <a:solidFill>
-              <a:srgbClr val="2E75B6"/>
-            </a:solidFill>
-            <a:prstDash val="solid"/>
-          </a:ln>
-        </p:spPr>
-        <p:txBody>
-          <a:bodyPr/>
-          <a:lstStyle/>
-          <a:p>
-            <a:endParaRPr lang="en-IN"/>
-          </a:p>
-        </p:txBody>
-      </p:sp>
-      <p:sp>
-        <p:nvSpPr>
-          <p:cNvPr id="4" name="Text 2"/>
-          <p:cNvSpPr/>
-          <p:nvPr/>
-        </p:nvSpPr>
-        <p:spPr>
-          <a:xfrm>
-            <a:off x="365760" y="73152"/>
-            <a:ext cx="6400800" cy="274320"/>
-          </a:xfrm>
-          <a:prstGeom prst="rect">
-            <a:avLst/>
-          </a:prstGeom>
-          <a:noFill/>
-          <a:ln/>
-        </p:spPr>
-        <p:txBody>
-          <a:bodyPr wrap="square" lIns="0" tIns="0" rIns="0" bIns="0" rtlCol="0" anchor="ctr"/>
-          <a:lstStyle/>
-          <a:p>
-            <a:pPr marL="0" indent="0">
-              <a:buNone/>
-            </a:pPr>
-            <a:r>
-              <a:rPr lang="en-US" sz="1800" b="1" dirty="0">
-                <a:solidFill>
-                  <a:srgbClr val="1F4E79"/>
-                </a:solidFill>
-                <a:latin typeface="Times New Roman" pitchFamily="34" charset="0"/>
-                <a:ea typeface="Times New Roman" pitchFamily="34" charset="-122"/>
-                <a:cs typeface="Times New Roman" pitchFamily="34" charset="-120"/>
-              </a:rPr>
-              <a:t>TCS349: Responsible and Explainable AI</a:t>
-            </a:r>
-            <a:endParaRPr lang="en-US" sz="1800" dirty="0"/>
-          </a:p>
-        </p:txBody>
-      </p:sp>
-      <p:sp>
-        <p:nvSpPr>
-          <p:cNvPr id="5" name="Text 3"/>
-          <p:cNvSpPr/>
-          <p:nvPr/>
-        </p:nvSpPr>
-        <p:spPr>
-          <a:xfrm>
-            <a:off x="8503920" y="82296"/>
-            <a:ext cx="3200400" cy="274320"/>
-          </a:xfrm>
-          <a:prstGeom prst="rect">
-            <a:avLst/>
-          </a:prstGeom>
-          <a:noFill/>
-          <a:ln/>
-        </p:spPr>
-        <p:txBody>
-          <a:bodyPr wrap="square" lIns="0" tIns="0" rIns="0" bIns="0" rtlCol="0" anchor="ctr"/>
-          <a:lstStyle/>
-          <a:p>
-            <a:pPr marL="0" indent="0" algn="r">
-              <a:buNone/>
-            </a:pPr>
-            <a:r>
-              <a:rPr lang="en-US" sz="1600" b="1" dirty="0">
-                <a:solidFill>
-                  <a:srgbClr val="1F4E79"/>
-                </a:solidFill>
-                <a:latin typeface="Times New Roman" pitchFamily="34" charset="0"/>
-                <a:ea typeface="Times New Roman" pitchFamily="34" charset="-122"/>
-                <a:cs typeface="Times New Roman" pitchFamily="34" charset="-120"/>
-              </a:rPr>
-              <a:t>Unit 1 | Lecture 7</a:t>
-            </a:r>
-            <a:endParaRPr lang="en-US" sz="1600" dirty="0"/>
-          </a:p>
-        </p:txBody>
-      </p:sp>
-      <p:sp>
-        <p:nvSpPr>
-          <p:cNvPr id="6" name="Text 4"/>
-          <p:cNvSpPr/>
-          <p:nvPr/>
-        </p:nvSpPr>
-        <p:spPr>
-          <a:xfrm>
-            <a:off x="502920" y="658368"/>
-            <a:ext cx="11155680" cy="640080"/>
-          </a:xfrm>
-          <a:prstGeom prst="rect">
-            <a:avLst/>
-          </a:prstGeom>
-          <a:noFill/>
-          <a:ln/>
-        </p:spPr>
-        <p:txBody>
-          <a:bodyPr wrap="square" lIns="0" tIns="0" rIns="0" bIns="0" rtlCol="0" anchor="ctr"/>
-          <a:lstStyle/>
-          <a:p>
-            <a:pPr marL="0" indent="0">
-              <a:buNone/>
-            </a:pPr>
-            <a:r>
-              <a:rPr lang="en-US" sz="2400" b="1" dirty="0">
-                <a:solidFill>
-                  <a:srgbClr val="1F4E79"/>
-                </a:solidFill>
-                <a:latin typeface="Times New Roman" pitchFamily="34" charset="0"/>
-                <a:ea typeface="Times New Roman" pitchFamily="34" charset="-122"/>
-                <a:cs typeface="Times New Roman" pitchFamily="34" charset="-120"/>
-              </a:rPr>
-              <a:t>8. From Detecting Bias to Defining Fairness</a:t>
-            </a:r>
-            <a:endParaRPr lang="en-US" sz="2400" dirty="0"/>
-          </a:p>
-        </p:txBody>
-      </p:sp>
-      <p:sp>
-        <p:nvSpPr>
-          <p:cNvPr id="7" name="Text 5"/>
-          <p:cNvSpPr/>
-          <p:nvPr/>
-        </p:nvSpPr>
-        <p:spPr>
-          <a:xfrm>
-            <a:off x="594360" y="1463040"/>
-            <a:ext cx="10972800" cy="4206240"/>
-          </a:xfrm>
-          <a:prstGeom prst="rect">
-            <a:avLst/>
-          </a:prstGeom>
-          <a:noFill/>
-          <a:ln/>
-        </p:spPr>
-        <p:txBody>
-          <a:bodyPr wrap="square" lIns="50800" tIns="50800" rIns="50800" bIns="50800" rtlCol="0" anchor="ctr"/>
-          <a:lstStyle/>
-          <a:p>
-            <a:pPr marL="0" indent="0">
-              <a:buNone/>
-            </a:pPr>
-            <a:r>
-              <a:rPr lang="en-US" sz="1800" dirty="0">
-                <a:solidFill>
-                  <a:srgbClr val="191919"/>
-                </a:solidFill>
-                <a:latin typeface="Times New Roman" pitchFamily="34" charset="0"/>
-                <a:ea typeface="Times New Roman" pitchFamily="34" charset="-122"/>
-                <a:cs typeface="Times New Roman" pitchFamily="34" charset="-120"/>
-              </a:rPr>
-              <a:t>Detecting a numeric gap tells us bias exists - it does not tell us what a "fair" outcome should look like.</a:t>
-            </a:r>
-            <a:endParaRPr lang="en-US" sz="1800" dirty="0"/>
-          </a:p>
-          <a:p>
-            <a:pPr marL="0" indent="0">
-              <a:buNone/>
-            </a:pPr>
-            <a:endParaRPr lang="en-US" sz="1800" dirty="0"/>
-          </a:p>
-          <a:p>
-            <a:pPr marL="0" indent="0">
-              <a:buNone/>
-            </a:pPr>
-            <a:r>
-              <a:rPr lang="en-US" sz="1800" dirty="0">
-                <a:solidFill>
-                  <a:srgbClr val="191919"/>
-                </a:solidFill>
-                <a:latin typeface="Times New Roman" pitchFamily="34" charset="0"/>
-                <a:ea typeface="Times New Roman" pitchFamily="34" charset="-122"/>
-                <a:cs typeface="Times New Roman" pitchFamily="34" charset="-120"/>
-              </a:rPr>
-              <a:t>Fairness in AI is the formal, mathematical attempt to define equitable treatment across individuals and groups.</a:t>
-            </a:r>
-            <a:endParaRPr lang="en-US" sz="1800" dirty="0"/>
-          </a:p>
-          <a:p>
-            <a:pPr marL="0" indent="0">
-              <a:buNone/>
-            </a:pPr>
-            <a:endParaRPr lang="en-US" sz="1800" dirty="0"/>
-          </a:p>
-          <a:p>
-            <a:pPr marL="0" indent="0">
-              <a:buNone/>
-            </a:pPr>
-            <a:r>
-              <a:rPr lang="en-US" sz="1800" dirty="0">
-                <a:solidFill>
-                  <a:srgbClr val="191919"/>
-                </a:solidFill>
-                <a:latin typeface="Times New Roman" pitchFamily="34" charset="0"/>
-                <a:ea typeface="Times New Roman" pitchFamily="34" charset="-122"/>
-                <a:cs typeface="Times New Roman" pitchFamily="34" charset="-120"/>
-              </a:rPr>
-              <a:t>There is no single universal definition of fairness - the appropriate notion depends on context and stakes.</a:t>
-            </a:r>
-            <a:endParaRPr lang="en-US" sz="1800" dirty="0"/>
-          </a:p>
-          <a:p>
-            <a:pPr marL="0" indent="0">
-              <a:buNone/>
-            </a:pPr>
-            <a:endParaRPr lang="en-US" sz="1800" dirty="0"/>
-          </a:p>
-          <a:p>
-            <a:pPr marL="0" indent="0">
-              <a:buNone/>
-            </a:pPr>
-            <a:r>
-              <a:rPr lang="en-US" sz="1800" dirty="0">
-                <a:solidFill>
-                  <a:srgbClr val="191919"/>
-                </a:solidFill>
-                <a:latin typeface="Times New Roman" pitchFamily="34" charset="0"/>
-                <a:ea typeface="Times New Roman" pitchFamily="34" charset="-122"/>
-                <a:cs typeface="Times New Roman" pitchFamily="34" charset="-120"/>
-              </a:rPr>
-              <a:t>The rest of this session introduces the two broad families: group fairness and individual fairness.</a:t>
-            </a:r>
-            <a:endParaRPr lang="en-US" sz="1800" dirty="0"/>
-          </a:p>
-        </p:txBody>
-      </p:sp>
-      <p:sp>
-        <p:nvSpPr>
-          <p:cNvPr id="8" name="Text 6"/>
-          <p:cNvSpPr/>
-          <p:nvPr/>
-        </p:nvSpPr>
-        <p:spPr>
-          <a:xfrm>
-            <a:off x="502920" y="5989320"/>
-            <a:ext cx="10744200" cy="411480"/>
-          </a:xfrm>
-          <a:prstGeom prst="rect">
-            <a:avLst/>
-          </a:prstGeom>
-          <a:noFill/>
-          <a:ln/>
-        </p:spPr>
-        <p:txBody>
-          <a:bodyPr wrap="square" lIns="0" tIns="0" rIns="0" bIns="0" rtlCol="0" anchor="ctr"/>
-          <a:lstStyle/>
-          <a:p>
-            <a:pPr marL="0" indent="0">
-              <a:buNone/>
-            </a:pPr>
-            <a:r>
-              <a:rPr lang="en-US" sz="1200" i="1" dirty="0">
-                <a:solidFill>
-                  <a:srgbClr val="595959"/>
-                </a:solidFill>
-                <a:latin typeface="Times New Roman" pitchFamily="34" charset="0"/>
-                <a:ea typeface="Times New Roman" pitchFamily="34" charset="-122"/>
-                <a:cs typeface="Times New Roman" pitchFamily="34" charset="-120"/>
-              </a:rPr>
-              <a:t>Teaching cue: Stress that choosing a fairness definition is a value judgement, not a purely technical decision.</a:t>
-            </a:r>
-            <a:endParaRPr lang="en-US" sz="1200" dirty="0"/>
-          </a:p>
-        </p:txBody>
-      </p:sp>
-      <p:sp>
-        <p:nvSpPr>
-          <p:cNvPr id="9" name="Text 7"/>
-          <p:cNvSpPr/>
-          <p:nvPr/>
-        </p:nvSpPr>
-        <p:spPr>
-          <a:xfrm>
-            <a:off x="11430000" y="6446520"/>
-            <a:ext cx="365760" cy="182880"/>
-          </a:xfrm>
-          <a:prstGeom prst="rect">
-            <a:avLst/>
-          </a:prstGeom>
-          <a:noFill/>
-          <a:ln/>
-        </p:spPr>
-        <p:txBody>
-          <a:bodyPr wrap="square" lIns="0" tIns="0" rIns="0" bIns="0" rtlCol="0" anchor="ctr"/>
-          <a:lstStyle/>
-          <a:p>
-            <a:pPr marL="0" indent="0" algn="ctr">
-              <a:buNone/>
-            </a:pPr>
-            <a:r>
-              <a:rPr lang="en-US" sz="1200" dirty="0">
-                <a:solidFill>
-                  <a:srgbClr val="595959"/>
-                </a:solidFill>
-                <a:latin typeface="Times New Roman" pitchFamily="34" charset="0"/>
-                <a:ea typeface="Times New Roman" pitchFamily="34" charset="-122"/>
-                <a:cs typeface="Times New Roman" pitchFamily="34" charset="-120"/>
-              </a:rPr>
-              <a:t>11</a:t>
-            </a:r>
-            <a:endParaRPr lang="en-US" sz="1200" dirty="0"/>
-          </a:p>
-        </p:txBody>
-      </p:sp>
-    </p:spTree>
-  </p:cSld>
-  <p:clrMapOvr>
-    <a:masterClrMapping/>
-  </p:clrMapOvr>
-</p:sld>
-</file>
-
-<file path=ppt/slides/slide12.xml><?xml version="1.0" encoding="utf-8"?>
 <p:sld xmlns:a="http://schemas.openxmlformats.org/drawingml/2006/main" xmlns:r="http://schemas.openxmlformats.org/officeDocument/2006/relationships" xmlns:p="http://schemas.openxmlformats.org/presentationml/2006/main">
   <p:cSld name="Slide 12">
     <p:bg>
@@ -4252,45 +3084,6 @@
       </p:sp>
       <p:sp>
         <p:nvSpPr>
-          <p:cNvPr id="8" name="Text 6"/>
-          <p:cNvSpPr/>
-          <p:nvPr/>
-        </p:nvSpPr>
-        <p:spPr>
-          <a:xfrm>
-            <a:off x="502920" y="5989320"/>
-            <a:ext cx="10744200" cy="411480"/>
-          </a:xfrm>
-          <a:prstGeom prst="rect">
-            <a:avLst/>
-          </a:prstGeom>
-          <a:noFill/>
-          <a:ln/>
-        </p:spPr>
-        <p:txBody>
-          <a:bodyPr wrap="square" lIns="0" tIns="0" rIns="0" bIns="0" rtlCol="0" anchor="ctr"/>
-          <a:lstStyle/>
-          <a:p>
-            <a:pPr marL="0" indent="0">
-              <a:buNone/>
-            </a:pPr>
-            <a:r>
-              <a:rPr lang="en-US" sz="1200" i="1" dirty="0">
-                <a:solidFill>
-                  <a:srgbClr val="595959"/>
-                </a:solidFill>
-                <a:latin typeface="Times New Roman" pitchFamily="34" charset="0"/>
-                <a:ea typeface="Times New Roman" pitchFamily="34" charset="-122"/>
-                <a:cs typeface="Times New Roman" pitchFamily="34" charset="-120"/>
-              </a:rPr>
-              <a:t>Teaching cue: Link back to the worked example — ask whether Group A and B would need equal approval rates.</a:t>
-            </a:r>
-            <a:endParaRPr lang="en-US" sz="1200" dirty="0"/>
-          </a:p>
-        </p:txBody>
-      </p:sp>
-      <p:sp>
-        <p:nvSpPr>
           <p:cNvPr id="9" name="Text 7"/>
           <p:cNvSpPr/>
           <p:nvPr/>
@@ -4336,7 +3129,7 @@
 </p:sld>
 </file>
 
-<file path=ppt/slides/slide13.xml><?xml version="1.0" encoding="utf-8"?>
+<file path=ppt/slides/slide11.xml><?xml version="1.0" encoding="utf-8"?>
 <p:sld xmlns:a="http://schemas.openxmlformats.org/drawingml/2006/main" xmlns:r="http://schemas.openxmlformats.org/officeDocument/2006/relationships" xmlns:p="http://schemas.openxmlformats.org/presentationml/2006/main">
   <p:cSld name="Slide 13">
     <p:bg>
@@ -4652,45 +3445,6 @@
       </p:sp>
       <p:sp>
         <p:nvSpPr>
-          <p:cNvPr id="8" name="Text 6"/>
-          <p:cNvSpPr/>
-          <p:nvPr/>
-        </p:nvSpPr>
-        <p:spPr>
-          <a:xfrm>
-            <a:off x="502920" y="5989320"/>
-            <a:ext cx="10744200" cy="411480"/>
-          </a:xfrm>
-          <a:prstGeom prst="rect">
-            <a:avLst/>
-          </a:prstGeom>
-          <a:noFill/>
-          <a:ln/>
-        </p:spPr>
-        <p:txBody>
-          <a:bodyPr wrap="square" lIns="0" tIns="0" rIns="0" bIns="0" rtlCol="0" anchor="ctr"/>
-          <a:lstStyle/>
-          <a:p>
-            <a:pPr marL="0" indent="0">
-              <a:buNone/>
-            </a:pPr>
-            <a:r>
-              <a:rPr lang="en-US" sz="1200" i="1" dirty="0">
-                <a:solidFill>
-                  <a:srgbClr val="595959"/>
-                </a:solidFill>
-                <a:latin typeface="Times New Roman" pitchFamily="34" charset="0"/>
-                <a:ea typeface="Times New Roman" pitchFamily="34" charset="-122"/>
-                <a:cs typeface="Times New Roman" pitchFamily="34" charset="-120"/>
-              </a:rPr>
-              <a:t>Teaching cue: Keep this introductory — the full trade-off analysis is reserved for Lecture 8, so avoid over-extending here.</a:t>
-            </a:r>
-            <a:endParaRPr lang="en-US" sz="1200" dirty="0"/>
-          </a:p>
-        </p:txBody>
-      </p:sp>
-      <p:sp>
-        <p:nvSpPr>
           <p:cNvPr id="9" name="Text 7"/>
           <p:cNvSpPr/>
           <p:nvPr/>
@@ -4736,7 +3490,7 @@
 </p:sld>
 </file>
 
-<file path=ppt/slides/slide14.xml><?xml version="1.0" encoding="utf-8"?>
+<file path=ppt/slides/slide12.xml><?xml version="1.0" encoding="utf-8"?>
 <p:sld xmlns:a="http://schemas.openxmlformats.org/drawingml/2006/main" xmlns:r="http://schemas.openxmlformats.org/officeDocument/2006/relationships" xmlns:p="http://schemas.openxmlformats.org/presentationml/2006/main">
   <p:cSld name="Slide 14">
     <p:bg>
@@ -5052,45 +3806,6 @@
       </p:sp>
       <p:sp>
         <p:nvSpPr>
-          <p:cNvPr id="8" name="Text 6"/>
-          <p:cNvSpPr/>
-          <p:nvPr/>
-        </p:nvSpPr>
-        <p:spPr>
-          <a:xfrm>
-            <a:off x="502920" y="5989320"/>
-            <a:ext cx="10744200" cy="411480"/>
-          </a:xfrm>
-          <a:prstGeom prst="rect">
-            <a:avLst/>
-          </a:prstGeom>
-          <a:noFill/>
-          <a:ln/>
-        </p:spPr>
-        <p:txBody>
-          <a:bodyPr wrap="square" lIns="0" tIns="0" rIns="0" bIns="0" rtlCol="0" anchor="ctr"/>
-          <a:lstStyle/>
-          <a:p>
-            <a:pPr marL="0" indent="0">
-              <a:buNone/>
-            </a:pPr>
-            <a:r>
-              <a:rPr lang="en-US" sz="1200" i="1" dirty="0">
-                <a:solidFill>
-                  <a:srgbClr val="595959"/>
-                </a:solidFill>
-                <a:latin typeface="Times New Roman" pitchFamily="34" charset="0"/>
-                <a:ea typeface="Times New Roman" pitchFamily="34" charset="-122"/>
-                <a:cs typeface="Times New Roman" pitchFamily="34" charset="-120"/>
-              </a:rPr>
-              <a:t>Teaching cue: Two applicants with near-identical profiles should receive near-identical decisions.</a:t>
-            </a:r>
-            <a:endParaRPr lang="en-US" sz="1200" dirty="0"/>
-          </a:p>
-        </p:txBody>
-      </p:sp>
-      <p:sp>
-        <p:nvSpPr>
           <p:cNvPr id="9" name="Text 7"/>
           <p:cNvSpPr/>
           <p:nvPr/>
@@ -5136,7 +3851,7 @@
 </p:sld>
 </file>
 
-<file path=ppt/slides/slide15.xml><?xml version="1.0" encoding="utf-8"?>
+<file path=ppt/slides/slide13.xml><?xml version="1.0" encoding="utf-8"?>
 <p:sld xmlns:a="http://schemas.openxmlformats.org/drawingml/2006/main" xmlns:r="http://schemas.openxmlformats.org/officeDocument/2006/relationships" xmlns:p="http://schemas.openxmlformats.org/presentationml/2006/main">
   <p:cSld name="Slide 15">
     <p:bg>
@@ -6448,45 +5163,6 @@
       </p:graphicFrame>
       <p:sp>
         <p:nvSpPr>
-          <p:cNvPr id="8" name="Text 5"/>
-          <p:cNvSpPr/>
-          <p:nvPr/>
-        </p:nvSpPr>
-        <p:spPr>
-          <a:xfrm>
-            <a:off x="502920" y="5989320"/>
-            <a:ext cx="10744200" cy="411480"/>
-          </a:xfrm>
-          <a:prstGeom prst="rect">
-            <a:avLst/>
-          </a:prstGeom>
-          <a:noFill/>
-          <a:ln/>
-        </p:spPr>
-        <p:txBody>
-          <a:bodyPr wrap="square" lIns="0" tIns="0" rIns="0" bIns="0" rtlCol="0" anchor="ctr"/>
-          <a:lstStyle/>
-          <a:p>
-            <a:pPr marL="0" indent="0">
-              <a:buNone/>
-            </a:pPr>
-            <a:r>
-              <a:rPr lang="en-US" sz="1200" i="1" dirty="0">
-                <a:solidFill>
-                  <a:srgbClr val="595959"/>
-                </a:solidFill>
-                <a:latin typeface="Times New Roman" pitchFamily="34" charset="0"/>
-                <a:ea typeface="Times New Roman" pitchFamily="34" charset="-122"/>
-                <a:cs typeface="Times New Roman" pitchFamily="34" charset="-120"/>
-              </a:rPr>
-              <a:t>Teaching cue: Ask students which notion suits a hiring AI versus a healthcare triage AI, and why.</a:t>
-            </a:r>
-            <a:endParaRPr lang="en-US" sz="1200" dirty="0"/>
-          </a:p>
-        </p:txBody>
-      </p:sp>
-      <p:sp>
-        <p:nvSpPr>
           <p:cNvPr id="9" name="Text 6"/>
           <p:cNvSpPr/>
           <p:nvPr/>
@@ -6532,876 +5208,7 @@
 </p:sld>
 </file>
 
-<file path=ppt/slides/slide16.xml><?xml version="1.0" encoding="utf-8"?>
-<p:sld xmlns:a="http://schemas.openxmlformats.org/drawingml/2006/main" xmlns:r="http://schemas.openxmlformats.org/officeDocument/2006/relationships" xmlns:p="http://schemas.openxmlformats.org/presentationml/2006/main">
-  <p:cSld name="Slide 16">
-    <p:bg>
-      <p:bgPr>
-        <a:solidFill>
-          <a:srgbClr val="FFFFFF"/>
-        </a:solidFill>
-        <a:effectLst/>
-      </p:bgPr>
-    </p:bg>
-    <p:spTree>
-      <p:nvGrpSpPr>
-        <p:cNvPr id="1" name=""/>
-        <p:cNvGrpSpPr/>
-        <p:nvPr/>
-      </p:nvGrpSpPr>
-      <p:grpSpPr>
-        <a:xfrm>
-          <a:off x="0" y="0"/>
-          <a:ext cx="0" cy="0"/>
-          <a:chOff x="0" y="0"/>
-          <a:chExt cx="0" cy="0"/>
-        </a:xfrm>
-      </p:grpSpPr>
-      <p:sp>
-        <p:nvSpPr>
-          <p:cNvPr id="2" name="Shape 0"/>
-          <p:cNvSpPr/>
-          <p:nvPr/>
-        </p:nvSpPr>
-        <p:spPr>
-          <a:xfrm>
-            <a:off x="0" y="0"/>
-            <a:ext cx="12191695" cy="502920"/>
-          </a:xfrm>
-          <a:prstGeom prst="rect">
-            <a:avLst/>
-          </a:prstGeom>
-          <a:solidFill>
-            <a:srgbClr val="F8FBFF"/>
-          </a:solidFill>
-          <a:ln w="12700">
-            <a:solidFill>
-              <a:srgbClr val="F8FBFF"/>
-            </a:solidFill>
-            <a:prstDash val="solid"/>
-          </a:ln>
-        </p:spPr>
-        <p:txBody>
-          <a:bodyPr/>
-          <a:lstStyle/>
-          <a:p>
-            <a:endParaRPr lang="en-IN"/>
-          </a:p>
-        </p:txBody>
-      </p:sp>
-      <p:sp>
-        <p:nvSpPr>
-          <p:cNvPr id="3" name="Shape 1"/>
-          <p:cNvSpPr/>
-          <p:nvPr/>
-        </p:nvSpPr>
-        <p:spPr>
-          <a:xfrm>
-            <a:off x="0" y="475488"/>
-            <a:ext cx="12191695" cy="27432"/>
-          </a:xfrm>
-          <a:prstGeom prst="rect">
-            <a:avLst/>
-          </a:prstGeom>
-          <a:solidFill>
-            <a:srgbClr val="2E75B6"/>
-          </a:solidFill>
-          <a:ln w="12700">
-            <a:solidFill>
-              <a:srgbClr val="2E75B6"/>
-            </a:solidFill>
-            <a:prstDash val="solid"/>
-          </a:ln>
-        </p:spPr>
-        <p:txBody>
-          <a:bodyPr/>
-          <a:lstStyle/>
-          <a:p>
-            <a:endParaRPr lang="en-IN"/>
-          </a:p>
-        </p:txBody>
-      </p:sp>
-      <p:sp>
-        <p:nvSpPr>
-          <p:cNvPr id="4" name="Text 2"/>
-          <p:cNvSpPr/>
-          <p:nvPr/>
-        </p:nvSpPr>
-        <p:spPr>
-          <a:xfrm>
-            <a:off x="365760" y="73152"/>
-            <a:ext cx="6400800" cy="274320"/>
-          </a:xfrm>
-          <a:prstGeom prst="rect">
-            <a:avLst/>
-          </a:prstGeom>
-          <a:noFill/>
-          <a:ln/>
-        </p:spPr>
-        <p:txBody>
-          <a:bodyPr wrap="square" lIns="0" tIns="0" rIns="0" bIns="0" rtlCol="0" anchor="ctr"/>
-          <a:lstStyle/>
-          <a:p>
-            <a:pPr marL="0" indent="0">
-              <a:buNone/>
-            </a:pPr>
-            <a:r>
-              <a:rPr lang="en-US" sz="1800" b="1" dirty="0">
-                <a:solidFill>
-                  <a:srgbClr val="1F4E79"/>
-                </a:solidFill>
-                <a:latin typeface="Times New Roman" pitchFamily="34" charset="0"/>
-                <a:ea typeface="Times New Roman" pitchFamily="34" charset="-122"/>
-                <a:cs typeface="Times New Roman" pitchFamily="34" charset="-120"/>
-              </a:rPr>
-              <a:t>TCS349: Responsible and Explainable AI</a:t>
-            </a:r>
-            <a:endParaRPr lang="en-US" sz="1800" dirty="0"/>
-          </a:p>
-        </p:txBody>
-      </p:sp>
-      <p:sp>
-        <p:nvSpPr>
-          <p:cNvPr id="5" name="Text 3"/>
-          <p:cNvSpPr/>
-          <p:nvPr/>
-        </p:nvSpPr>
-        <p:spPr>
-          <a:xfrm>
-            <a:off x="8503920" y="82296"/>
-            <a:ext cx="3200400" cy="274320"/>
-          </a:xfrm>
-          <a:prstGeom prst="rect">
-            <a:avLst/>
-          </a:prstGeom>
-          <a:noFill/>
-          <a:ln/>
-        </p:spPr>
-        <p:txBody>
-          <a:bodyPr wrap="square" lIns="0" tIns="0" rIns="0" bIns="0" rtlCol="0" anchor="ctr"/>
-          <a:lstStyle/>
-          <a:p>
-            <a:pPr marL="0" indent="0" algn="r">
-              <a:buNone/>
-            </a:pPr>
-            <a:r>
-              <a:rPr lang="en-US" sz="1600" b="1" dirty="0">
-                <a:solidFill>
-                  <a:srgbClr val="1F4E79"/>
-                </a:solidFill>
-                <a:latin typeface="Times New Roman" pitchFamily="34" charset="0"/>
-                <a:ea typeface="Times New Roman" pitchFamily="34" charset="-122"/>
-                <a:cs typeface="Times New Roman" pitchFamily="34" charset="-120"/>
-              </a:rPr>
-              <a:t>Unit 1 | Lectures 6 &amp; 7</a:t>
-            </a:r>
-            <a:endParaRPr lang="en-US" sz="1600" dirty="0"/>
-          </a:p>
-        </p:txBody>
-      </p:sp>
-      <p:sp>
-        <p:nvSpPr>
-          <p:cNvPr id="6" name="Text 4"/>
-          <p:cNvSpPr/>
-          <p:nvPr/>
-        </p:nvSpPr>
-        <p:spPr>
-          <a:xfrm>
-            <a:off x="502920" y="658368"/>
-            <a:ext cx="11155680" cy="640080"/>
-          </a:xfrm>
-          <a:prstGeom prst="rect">
-            <a:avLst/>
-          </a:prstGeom>
-          <a:noFill/>
-          <a:ln/>
-        </p:spPr>
-        <p:txBody>
-          <a:bodyPr wrap="square" lIns="0" tIns="0" rIns="0" bIns="0" rtlCol="0" anchor="ctr"/>
-          <a:lstStyle/>
-          <a:p>
-            <a:pPr marL="0" indent="0">
-              <a:buNone/>
-            </a:pPr>
-            <a:r>
-              <a:rPr lang="en-US" sz="2400" b="1" dirty="0">
-                <a:solidFill>
-                  <a:srgbClr val="1F4E79"/>
-                </a:solidFill>
-                <a:latin typeface="Times New Roman" pitchFamily="34" charset="0"/>
-                <a:ea typeface="Times New Roman" pitchFamily="34" charset="-122"/>
-                <a:cs typeface="Times New Roman" pitchFamily="34" charset="-120"/>
-              </a:rPr>
-              <a:t>Mini Classroom Activity</a:t>
-            </a:r>
-            <a:endParaRPr lang="en-US" sz="2400" dirty="0"/>
-          </a:p>
-        </p:txBody>
-      </p:sp>
-      <p:sp>
-        <p:nvSpPr>
-          <p:cNvPr id="7" name="Text 5"/>
-          <p:cNvSpPr/>
-          <p:nvPr/>
-        </p:nvSpPr>
-        <p:spPr>
-          <a:xfrm>
-            <a:off x="594360" y="1463040"/>
-            <a:ext cx="10972800" cy="4206240"/>
-          </a:xfrm>
-          <a:prstGeom prst="rect">
-            <a:avLst/>
-          </a:prstGeom>
-          <a:noFill/>
-          <a:ln/>
-        </p:spPr>
-        <p:txBody>
-          <a:bodyPr wrap="square" lIns="50800" tIns="50800" rIns="50800" bIns="50800" rtlCol="0" anchor="ctr"/>
-          <a:lstStyle/>
-          <a:p>
-            <a:pPr marL="0" indent="0">
-              <a:buNone/>
-            </a:pPr>
-            <a:r>
-              <a:rPr lang="en-US" sz="1800" dirty="0">
-                <a:solidFill>
-                  <a:srgbClr val="191919"/>
-                </a:solidFill>
-                <a:latin typeface="Times New Roman" pitchFamily="34" charset="0"/>
-                <a:ea typeface="Times New Roman" pitchFamily="34" charset="-122"/>
-                <a:cs typeface="Times New Roman" pitchFamily="34" charset="-120"/>
-              </a:rPr>
-              <a:t>Form groups of 3- 4 students.</a:t>
-            </a:r>
-            <a:endParaRPr lang="en-US" sz="1800" dirty="0"/>
-          </a:p>
-          <a:p>
-            <a:pPr marL="0" indent="0">
-              <a:buNone/>
-            </a:pPr>
-            <a:endParaRPr lang="en-US" sz="1800" dirty="0"/>
-          </a:p>
-          <a:p>
-            <a:pPr marL="0" indent="0">
-              <a:buNone/>
-            </a:pPr>
-            <a:r>
-              <a:rPr lang="en-US" sz="1800" dirty="0">
-                <a:solidFill>
-                  <a:srgbClr val="191919"/>
-                </a:solidFill>
-                <a:latin typeface="Times New Roman" pitchFamily="34" charset="0"/>
-                <a:ea typeface="Times New Roman" pitchFamily="34" charset="-122"/>
-                <a:cs typeface="Times New Roman" pitchFamily="34" charset="-120"/>
-              </a:rPr>
-              <a:t>Use the worked loan-approval example from this session (or choose a new AI system).</a:t>
-            </a:r>
-            <a:endParaRPr lang="en-US" sz="1800" dirty="0"/>
-          </a:p>
-          <a:p>
-            <a:pPr marL="0" indent="0">
-              <a:buNone/>
-            </a:pPr>
-            <a:endParaRPr lang="en-US" sz="1800" dirty="0"/>
-          </a:p>
-          <a:p>
-            <a:pPr marL="0" indent="0">
-              <a:buNone/>
-            </a:pPr>
-            <a:r>
-              <a:rPr lang="en-US" sz="1800" dirty="0">
-                <a:solidFill>
-                  <a:srgbClr val="191919"/>
-                </a:solidFill>
-                <a:latin typeface="Times New Roman" pitchFamily="34" charset="0"/>
-                <a:ea typeface="Times New Roman" pitchFamily="34" charset="-122"/>
-                <a:cs typeface="Times New Roman" pitchFamily="34" charset="-120"/>
-              </a:rPr>
-              <a:t>Compute the subgroup-wise TPR, FPR and FNR for the given numbers.</a:t>
-            </a:r>
-            <a:endParaRPr lang="en-US" sz="1800" dirty="0"/>
-          </a:p>
-          <a:p>
-            <a:pPr marL="0" indent="0">
-              <a:buNone/>
-            </a:pPr>
-            <a:endParaRPr lang="en-US" sz="1800" dirty="0"/>
-          </a:p>
-          <a:p>
-            <a:pPr marL="0" indent="0">
-              <a:buNone/>
-            </a:pPr>
-            <a:r>
-              <a:rPr lang="en-US" sz="1800" dirty="0">
-                <a:solidFill>
-                  <a:srgbClr val="191919"/>
-                </a:solidFill>
-                <a:latin typeface="Times New Roman" pitchFamily="34" charset="0"/>
-                <a:ea typeface="Times New Roman" pitchFamily="34" charset="-122"/>
-                <a:cs typeface="Times New Roman" pitchFamily="34" charset="-120"/>
-              </a:rPr>
-              <a:t>Decide which group-fairness notion - demographic parity, equal opportunity or equalized odds - is satisfied or violated.</a:t>
-            </a:r>
-            <a:endParaRPr lang="en-US" sz="1800" dirty="0"/>
-          </a:p>
-          <a:p>
-            <a:pPr marL="0" indent="0">
-              <a:buNone/>
-            </a:pPr>
-            <a:endParaRPr lang="en-US" sz="1800" dirty="0"/>
-          </a:p>
-          <a:p>
-            <a:pPr marL="0" indent="0">
-              <a:buNone/>
-            </a:pPr>
-            <a:r>
-              <a:rPr lang="en-US" sz="1800" dirty="0">
-                <a:solidFill>
-                  <a:srgbClr val="191919"/>
-                </a:solidFill>
-                <a:latin typeface="Times New Roman" pitchFamily="34" charset="0"/>
-                <a:ea typeface="Times New Roman" pitchFamily="34" charset="-122"/>
-                <a:cs typeface="Times New Roman" pitchFamily="34" charset="-120"/>
-              </a:rPr>
-              <a:t>Each group shares one key finding in 1 minute.</a:t>
-            </a:r>
-            <a:endParaRPr lang="en-US" sz="1800" dirty="0"/>
-          </a:p>
-        </p:txBody>
-      </p:sp>
-      <p:sp>
-        <p:nvSpPr>
-          <p:cNvPr id="8" name="Text 6"/>
-          <p:cNvSpPr/>
-          <p:nvPr/>
-        </p:nvSpPr>
-        <p:spPr>
-          <a:xfrm>
-            <a:off x="502920" y="5989320"/>
-            <a:ext cx="10744200" cy="411480"/>
-          </a:xfrm>
-          <a:prstGeom prst="rect">
-            <a:avLst/>
-          </a:prstGeom>
-          <a:noFill/>
-          <a:ln/>
-        </p:spPr>
-        <p:txBody>
-          <a:bodyPr wrap="square" lIns="0" tIns="0" rIns="0" bIns="0" rtlCol="0" anchor="ctr"/>
-          <a:lstStyle/>
-          <a:p>
-            <a:pPr marL="0" indent="0">
-              <a:buNone/>
-            </a:pPr>
-            <a:r>
-              <a:rPr lang="en-US" sz="1200" i="1" dirty="0">
-                <a:solidFill>
-                  <a:srgbClr val="595959"/>
-                </a:solidFill>
-                <a:latin typeface="Times New Roman" pitchFamily="34" charset="0"/>
-                <a:ea typeface="Times New Roman" pitchFamily="34" charset="-122"/>
-                <a:cs typeface="Times New Roman" pitchFamily="34" charset="-120"/>
-              </a:rPr>
-              <a:t>Teaching cue: This activity checks whether students can move from numeric detection to a fairness judgement.</a:t>
-            </a:r>
-            <a:endParaRPr lang="en-US" sz="1200" dirty="0"/>
-          </a:p>
-        </p:txBody>
-      </p:sp>
-      <p:sp>
-        <p:nvSpPr>
-          <p:cNvPr id="9" name="Text 7"/>
-          <p:cNvSpPr/>
-          <p:nvPr/>
-        </p:nvSpPr>
-        <p:spPr>
-          <a:xfrm>
-            <a:off x="11430000" y="6446520"/>
-            <a:ext cx="365760" cy="182880"/>
-          </a:xfrm>
-          <a:prstGeom prst="rect">
-            <a:avLst/>
-          </a:prstGeom>
-          <a:noFill/>
-          <a:ln/>
-        </p:spPr>
-        <p:txBody>
-          <a:bodyPr wrap="square" lIns="0" tIns="0" rIns="0" bIns="0" rtlCol="0" anchor="ctr"/>
-          <a:lstStyle/>
-          <a:p>
-            <a:pPr marL="0" indent="0" algn="ctr">
-              <a:buNone/>
-            </a:pPr>
-            <a:r>
-              <a:rPr lang="en-US" sz="1200" dirty="0">
-                <a:solidFill>
-                  <a:srgbClr val="595959"/>
-                </a:solidFill>
-                <a:latin typeface="Times New Roman" pitchFamily="34" charset="0"/>
-                <a:ea typeface="Times New Roman" pitchFamily="34" charset="-122"/>
-                <a:cs typeface="Times New Roman" pitchFamily="34" charset="-120"/>
-              </a:rPr>
-              <a:t>16</a:t>
-            </a:r>
-            <a:endParaRPr lang="en-US" sz="1200" dirty="0"/>
-          </a:p>
-        </p:txBody>
-      </p:sp>
-    </p:spTree>
-  </p:cSld>
-  <p:clrMapOvr>
-    <a:masterClrMapping/>
-  </p:clrMapOvr>
-</p:sld>
-</file>
-
-<file path=ppt/slides/slide17.xml><?xml version="1.0" encoding="utf-8"?>
-<p:sld xmlns:a="http://schemas.openxmlformats.org/drawingml/2006/main" xmlns:r="http://schemas.openxmlformats.org/officeDocument/2006/relationships" xmlns:p="http://schemas.openxmlformats.org/presentationml/2006/main">
-  <p:cSld name="Slide 17">
-    <p:bg>
-      <p:bgPr>
-        <a:solidFill>
-          <a:srgbClr val="FFFFFF"/>
-        </a:solidFill>
-        <a:effectLst/>
-      </p:bgPr>
-    </p:bg>
-    <p:spTree>
-      <p:nvGrpSpPr>
-        <p:cNvPr id="1" name=""/>
-        <p:cNvGrpSpPr/>
-        <p:nvPr/>
-      </p:nvGrpSpPr>
-      <p:grpSpPr>
-        <a:xfrm>
-          <a:off x="0" y="0"/>
-          <a:ext cx="0" cy="0"/>
-          <a:chOff x="0" y="0"/>
-          <a:chExt cx="0" cy="0"/>
-        </a:xfrm>
-      </p:grpSpPr>
-      <p:sp>
-        <p:nvSpPr>
-          <p:cNvPr id="2" name="Shape 0"/>
-          <p:cNvSpPr/>
-          <p:nvPr/>
-        </p:nvSpPr>
-        <p:spPr>
-          <a:xfrm>
-            <a:off x="0" y="0"/>
-            <a:ext cx="12191695" cy="502920"/>
-          </a:xfrm>
-          <a:prstGeom prst="rect">
-            <a:avLst/>
-          </a:prstGeom>
-          <a:solidFill>
-            <a:srgbClr val="F8FBFF"/>
-          </a:solidFill>
-          <a:ln w="12700">
-            <a:solidFill>
-              <a:srgbClr val="F8FBFF"/>
-            </a:solidFill>
-            <a:prstDash val="solid"/>
-          </a:ln>
-        </p:spPr>
-        <p:txBody>
-          <a:bodyPr/>
-          <a:lstStyle/>
-          <a:p>
-            <a:endParaRPr lang="en-IN"/>
-          </a:p>
-        </p:txBody>
-      </p:sp>
-      <p:sp>
-        <p:nvSpPr>
-          <p:cNvPr id="3" name="Shape 1"/>
-          <p:cNvSpPr/>
-          <p:nvPr/>
-        </p:nvSpPr>
-        <p:spPr>
-          <a:xfrm>
-            <a:off x="0" y="475488"/>
-            <a:ext cx="12191695" cy="27432"/>
-          </a:xfrm>
-          <a:prstGeom prst="rect">
-            <a:avLst/>
-          </a:prstGeom>
-          <a:solidFill>
-            <a:srgbClr val="2E75B6"/>
-          </a:solidFill>
-          <a:ln w="12700">
-            <a:solidFill>
-              <a:srgbClr val="2E75B6"/>
-            </a:solidFill>
-            <a:prstDash val="solid"/>
-          </a:ln>
-        </p:spPr>
-        <p:txBody>
-          <a:bodyPr/>
-          <a:lstStyle/>
-          <a:p>
-            <a:endParaRPr lang="en-IN"/>
-          </a:p>
-        </p:txBody>
-      </p:sp>
-      <p:sp>
-        <p:nvSpPr>
-          <p:cNvPr id="4" name="Text 2"/>
-          <p:cNvSpPr/>
-          <p:nvPr/>
-        </p:nvSpPr>
-        <p:spPr>
-          <a:xfrm>
-            <a:off x="365760" y="73152"/>
-            <a:ext cx="6400800" cy="274320"/>
-          </a:xfrm>
-          <a:prstGeom prst="rect">
-            <a:avLst/>
-          </a:prstGeom>
-          <a:noFill/>
-          <a:ln/>
-        </p:spPr>
-        <p:txBody>
-          <a:bodyPr wrap="square" lIns="0" tIns="0" rIns="0" bIns="0" rtlCol="0" anchor="ctr"/>
-          <a:lstStyle/>
-          <a:p>
-            <a:pPr marL="0" indent="0">
-              <a:buNone/>
-            </a:pPr>
-            <a:r>
-              <a:rPr lang="en-US" sz="1800" b="1" dirty="0">
-                <a:solidFill>
-                  <a:srgbClr val="1F4E79"/>
-                </a:solidFill>
-                <a:latin typeface="Times New Roman" pitchFamily="34" charset="0"/>
-                <a:ea typeface="Times New Roman" pitchFamily="34" charset="-122"/>
-                <a:cs typeface="Times New Roman" pitchFamily="34" charset="-120"/>
-              </a:rPr>
-              <a:t>TCS349: Responsible and Explainable AI</a:t>
-            </a:r>
-            <a:endParaRPr lang="en-US" sz="1800" dirty="0"/>
-          </a:p>
-        </p:txBody>
-      </p:sp>
-      <p:sp>
-        <p:nvSpPr>
-          <p:cNvPr id="5" name="Text 3"/>
-          <p:cNvSpPr/>
-          <p:nvPr/>
-        </p:nvSpPr>
-        <p:spPr>
-          <a:xfrm>
-            <a:off x="8503920" y="82296"/>
-            <a:ext cx="3200400" cy="274320"/>
-          </a:xfrm>
-          <a:prstGeom prst="rect">
-            <a:avLst/>
-          </a:prstGeom>
-          <a:noFill/>
-          <a:ln/>
-        </p:spPr>
-        <p:txBody>
-          <a:bodyPr wrap="square" lIns="0" tIns="0" rIns="0" bIns="0" rtlCol="0" anchor="ctr"/>
-          <a:lstStyle/>
-          <a:p>
-            <a:pPr marL="0" indent="0" algn="r">
-              <a:buNone/>
-            </a:pPr>
-            <a:r>
-              <a:rPr lang="en-US" sz="1600" b="1" dirty="0">
-                <a:solidFill>
-                  <a:srgbClr val="1F4E79"/>
-                </a:solidFill>
-                <a:latin typeface="Times New Roman" pitchFamily="34" charset="0"/>
-                <a:ea typeface="Times New Roman" pitchFamily="34" charset="-122"/>
-                <a:cs typeface="Times New Roman" pitchFamily="34" charset="-120"/>
-              </a:rPr>
-              <a:t>Unit 1 | Lectures 6 &amp; 7</a:t>
-            </a:r>
-            <a:endParaRPr lang="en-US" sz="1600" dirty="0"/>
-          </a:p>
-        </p:txBody>
-      </p:sp>
-      <p:sp>
-        <p:nvSpPr>
-          <p:cNvPr id="6" name="Text 4"/>
-          <p:cNvSpPr/>
-          <p:nvPr/>
-        </p:nvSpPr>
-        <p:spPr>
-          <a:xfrm>
-            <a:off x="502920" y="658368"/>
-            <a:ext cx="11155680" cy="640080"/>
-          </a:xfrm>
-          <a:prstGeom prst="rect">
-            <a:avLst/>
-          </a:prstGeom>
-          <a:noFill/>
-          <a:ln/>
-        </p:spPr>
-        <p:txBody>
-          <a:bodyPr wrap="square" lIns="0" tIns="0" rIns="0" bIns="0" rtlCol="0" anchor="ctr"/>
-          <a:lstStyle/>
-          <a:p>
-            <a:pPr marL="0" indent="0">
-              <a:buNone/>
-            </a:pPr>
-            <a:r>
-              <a:rPr lang="en-US" sz="2400" b="1" dirty="0">
-                <a:solidFill>
-                  <a:srgbClr val="1F4E79"/>
-                </a:solidFill>
-                <a:latin typeface="Times New Roman" pitchFamily="34" charset="0"/>
-                <a:ea typeface="Times New Roman" pitchFamily="34" charset="-122"/>
-                <a:cs typeface="Times New Roman" pitchFamily="34" charset="-120"/>
-              </a:rPr>
-              <a:t>Recap and Exit Questions</a:t>
-            </a:r>
-            <a:endParaRPr lang="en-US" sz="2400" dirty="0"/>
-          </a:p>
-        </p:txBody>
-      </p:sp>
-      <p:sp>
-        <p:nvSpPr>
-          <p:cNvPr id="7" name="Text 5"/>
-          <p:cNvSpPr/>
-          <p:nvPr/>
-        </p:nvSpPr>
-        <p:spPr>
-          <a:xfrm>
-            <a:off x="594360" y="1463040"/>
-            <a:ext cx="10972800" cy="4297680"/>
-          </a:xfrm>
-          <a:prstGeom prst="rect">
-            <a:avLst/>
-          </a:prstGeom>
-          <a:noFill/>
-          <a:ln/>
-        </p:spPr>
-        <p:txBody>
-          <a:bodyPr wrap="square" lIns="50800" tIns="50800" rIns="50800" bIns="50800" rtlCol="0" anchor="ctr"/>
-          <a:lstStyle/>
-          <a:p>
-            <a:pPr marL="0" indent="0">
-              <a:buNone/>
-            </a:pPr>
-            <a:r>
-              <a:rPr lang="en-US" sz="1650" dirty="0">
-                <a:solidFill>
-                  <a:srgbClr val="191919"/>
-                </a:solidFill>
-                <a:latin typeface="Times New Roman" pitchFamily="34" charset="0"/>
-                <a:ea typeface="Times New Roman" pitchFamily="34" charset="-122"/>
-                <a:cs typeface="Times New Roman" pitchFamily="34" charset="-120"/>
-              </a:rPr>
-              <a:t>Subgroup analysis reveals performance gaps that overall accuracy can hide; TPR, FPR and FNR quantify them numerically.</a:t>
-            </a:r>
-            <a:endParaRPr lang="en-US" sz="1650" dirty="0"/>
-          </a:p>
-          <a:p>
-            <a:pPr marL="0" indent="0">
-              <a:buNone/>
-            </a:pPr>
-            <a:endParaRPr lang="en-US" sz="1650" dirty="0"/>
-          </a:p>
-          <a:p>
-            <a:pPr marL="0" indent="0">
-              <a:buNone/>
-            </a:pPr>
-            <a:r>
-              <a:rPr lang="en-US" sz="1650" dirty="0">
-                <a:solidFill>
-                  <a:srgbClr val="191919"/>
-                </a:solidFill>
-                <a:latin typeface="Times New Roman" pitchFamily="34" charset="0"/>
-                <a:ea typeface="Times New Roman" pitchFamily="34" charset="-122"/>
-                <a:cs typeface="Times New Roman" pitchFamily="34" charset="-120"/>
-              </a:rPr>
-              <a:t>Group fairness - demographic parity, equal opportunity, equalized odds - formalises equitable treatment across groups.</a:t>
-            </a:r>
-            <a:endParaRPr lang="en-US" sz="1650" dirty="0"/>
-          </a:p>
-          <a:p>
-            <a:pPr marL="0" indent="0">
-              <a:buNone/>
-            </a:pPr>
-            <a:endParaRPr lang="en-US" sz="1650" dirty="0"/>
-          </a:p>
-          <a:p>
-            <a:pPr marL="0" indent="0">
-              <a:buNone/>
-            </a:pPr>
-            <a:r>
-              <a:rPr lang="en-US" sz="1650" dirty="0">
-                <a:solidFill>
-                  <a:srgbClr val="191919"/>
-                </a:solidFill>
-                <a:latin typeface="Times New Roman" pitchFamily="34" charset="0"/>
-                <a:ea typeface="Times New Roman" pitchFamily="34" charset="-122"/>
-                <a:cs typeface="Times New Roman" pitchFamily="34" charset="-120"/>
-              </a:rPr>
-              <a:t>Individual fairness requires that similar people receive similar outcomes.</a:t>
-            </a:r>
-            <a:endParaRPr lang="en-US" sz="1650" dirty="0"/>
-          </a:p>
-          <a:p>
-            <a:pPr marL="0" indent="0">
-              <a:buNone/>
-            </a:pPr>
-            <a:endParaRPr lang="en-US" sz="1650" dirty="0"/>
-          </a:p>
-          <a:p>
-            <a:pPr marL="0" indent="0">
-              <a:buNone/>
-            </a:pPr>
-            <a:r>
-              <a:rPr lang="en-US" sz="1650" dirty="0">
-                <a:solidFill>
-                  <a:srgbClr val="191919"/>
-                </a:solidFill>
-                <a:latin typeface="Times New Roman" pitchFamily="34" charset="0"/>
-                <a:ea typeface="Times New Roman" pitchFamily="34" charset="-122"/>
-                <a:cs typeface="Times New Roman" pitchFamily="34" charset="-120"/>
-              </a:rPr>
-              <a:t>1. Why can two groups share equal FPR but have very different FNR?</a:t>
-            </a:r>
-            <a:endParaRPr lang="en-US" sz="1650" dirty="0"/>
-          </a:p>
-          <a:p>
-            <a:pPr marL="0" indent="0">
-              <a:buNone/>
-            </a:pPr>
-            <a:endParaRPr lang="en-US" sz="1650" dirty="0"/>
-          </a:p>
-          <a:p>
-            <a:pPr marL="0" indent="0">
-              <a:buNone/>
-            </a:pPr>
-            <a:r>
-              <a:rPr lang="en-US" sz="1650" dirty="0">
-                <a:solidFill>
-                  <a:srgbClr val="191919"/>
-                </a:solidFill>
-                <a:latin typeface="Times New Roman" pitchFamily="34" charset="0"/>
-                <a:ea typeface="Times New Roman" pitchFamily="34" charset="-122"/>
-                <a:cs typeface="Times New Roman" pitchFamily="34" charset="-120"/>
-              </a:rPr>
-              <a:t>2. What is the difference between equal opportunity and equalized odds?</a:t>
-            </a:r>
-            <a:endParaRPr lang="en-US" sz="1650" dirty="0"/>
-          </a:p>
-          <a:p>
-            <a:pPr marL="0" indent="0">
-              <a:buNone/>
-            </a:pPr>
-            <a:endParaRPr lang="en-US" sz="1650" dirty="0"/>
-          </a:p>
-          <a:p>
-            <a:pPr marL="0" indent="0">
-              <a:buNone/>
-            </a:pPr>
-            <a:r>
-              <a:rPr lang="en-US" sz="1650" dirty="0">
-                <a:solidFill>
-                  <a:srgbClr val="191919"/>
-                </a:solidFill>
-                <a:latin typeface="Times New Roman" pitchFamily="34" charset="0"/>
-                <a:ea typeface="Times New Roman" pitchFamily="34" charset="-122"/>
-                <a:cs typeface="Times New Roman" pitchFamily="34" charset="-120"/>
-              </a:rPr>
-              <a:t>3. Give one example where individual and group fairness might conflict.</a:t>
-            </a:r>
-            <a:endParaRPr lang="en-US" sz="1650" dirty="0"/>
-          </a:p>
-        </p:txBody>
-      </p:sp>
-      <p:sp>
-        <p:nvSpPr>
-          <p:cNvPr id="8" name="Text 6"/>
-          <p:cNvSpPr/>
-          <p:nvPr/>
-        </p:nvSpPr>
-        <p:spPr>
-          <a:xfrm>
-            <a:off x="502920" y="5989320"/>
-            <a:ext cx="10744200" cy="411480"/>
-          </a:xfrm>
-          <a:prstGeom prst="rect">
-            <a:avLst/>
-          </a:prstGeom>
-          <a:noFill/>
-          <a:ln/>
-        </p:spPr>
-        <p:txBody>
-          <a:bodyPr wrap="square" lIns="0" tIns="0" rIns="0" bIns="0" rtlCol="0" anchor="ctr"/>
-          <a:lstStyle/>
-          <a:p>
-            <a:pPr marL="0" indent="0">
-              <a:buNone/>
-            </a:pPr>
-            <a:r>
-              <a:rPr lang="en-US" sz="1200" i="1" dirty="0">
-                <a:solidFill>
-                  <a:srgbClr val="595959"/>
-                </a:solidFill>
-                <a:latin typeface="Times New Roman" pitchFamily="34" charset="0"/>
-                <a:ea typeface="Times New Roman" pitchFamily="34" charset="-122"/>
-                <a:cs typeface="Times New Roman" pitchFamily="34" charset="-120"/>
-              </a:rPr>
-              <a:t>Next Lecture: Fairness metrics and trade-offs — equal opportunity, equalized odds and predictive parity.</a:t>
-            </a:r>
-            <a:endParaRPr lang="en-US" sz="1200" dirty="0"/>
-          </a:p>
-        </p:txBody>
-      </p:sp>
-      <p:sp>
-        <p:nvSpPr>
-          <p:cNvPr id="9" name="Text 7"/>
-          <p:cNvSpPr/>
-          <p:nvPr/>
-        </p:nvSpPr>
-        <p:spPr>
-          <a:xfrm>
-            <a:off x="11430000" y="6446520"/>
-            <a:ext cx="365760" cy="182880"/>
-          </a:xfrm>
-          <a:prstGeom prst="rect">
-            <a:avLst/>
-          </a:prstGeom>
-          <a:noFill/>
-          <a:ln/>
-        </p:spPr>
-        <p:txBody>
-          <a:bodyPr wrap="square" lIns="0" tIns="0" rIns="0" bIns="0" rtlCol="0" anchor="ctr"/>
-          <a:lstStyle/>
-          <a:p>
-            <a:pPr marL="0" indent="0" algn="ctr">
-              <a:buNone/>
-            </a:pPr>
-            <a:r>
-              <a:rPr lang="en-US" sz="1200" dirty="0">
-                <a:solidFill>
-                  <a:srgbClr val="595959"/>
-                </a:solidFill>
-                <a:latin typeface="Times New Roman" pitchFamily="34" charset="0"/>
-                <a:ea typeface="Times New Roman" pitchFamily="34" charset="-122"/>
-                <a:cs typeface="Times New Roman" pitchFamily="34" charset="-120"/>
-              </a:rPr>
-              <a:t>17</a:t>
-            </a:r>
-            <a:endParaRPr lang="en-US" sz="1200" dirty="0"/>
-          </a:p>
-        </p:txBody>
-      </p:sp>
-    </p:spTree>
-  </p:cSld>
-  <p:clrMapOvr>
-    <a:masterClrMapping/>
-  </p:clrMapOvr>
-</p:sld>
-</file>
-
-<file path=ppt/slides/slide18.xml><?xml version="1.0" encoding="utf-8"?>
+<file path=ppt/slides/slide14.xml><?xml version="1.0" encoding="utf-8"?>
 <p:sld xmlns:a="http://schemas.openxmlformats.org/drawingml/2006/main" xmlns:r="http://schemas.openxmlformats.org/officeDocument/2006/relationships" xmlns:p="http://schemas.openxmlformats.org/presentationml/2006/main">
   <p:cSld name="Slide 18">
     <p:bg>
@@ -7728,45 +5535,6 @@
       </p:sp>
       <p:sp>
         <p:nvSpPr>
-          <p:cNvPr id="8" name="Text 6"/>
-          <p:cNvSpPr/>
-          <p:nvPr/>
-        </p:nvSpPr>
-        <p:spPr>
-          <a:xfrm>
-            <a:off x="502920" y="5989320"/>
-            <a:ext cx="10744200" cy="411480"/>
-          </a:xfrm>
-          <a:prstGeom prst="rect">
-            <a:avLst/>
-          </a:prstGeom>
-          <a:noFill/>
-          <a:ln/>
-        </p:spPr>
-        <p:txBody>
-          <a:bodyPr wrap="square" lIns="0" tIns="0" rIns="0" bIns="0" rtlCol="0" anchor="ctr"/>
-          <a:lstStyle/>
-          <a:p>
-            <a:pPr marL="0" indent="0">
-              <a:buNone/>
-            </a:pPr>
-            <a:r>
-              <a:rPr lang="en-US" sz="1200" i="1" dirty="0">
-                <a:solidFill>
-                  <a:srgbClr val="595959"/>
-                </a:solidFill>
-                <a:latin typeface="Times New Roman" pitchFamily="34" charset="0"/>
-                <a:ea typeface="Times New Roman" pitchFamily="34" charset="-122"/>
-                <a:cs typeface="Times New Roman" pitchFamily="34" charset="-120"/>
-              </a:rPr>
-              <a:t>Teaching cue: These are the official Unit I self-learning and team activities — assign as homework or an in-class wrap-up.</a:t>
-            </a:r>
-            <a:endParaRPr lang="en-US" sz="1200" dirty="0"/>
-          </a:p>
-        </p:txBody>
-      </p:sp>
-      <p:sp>
-        <p:nvSpPr>
           <p:cNvPr id="9" name="Text 7"/>
           <p:cNvSpPr/>
           <p:nvPr/>
@@ -7813,875 +5581,6 @@
 </file>
 
 <file path=ppt/slides/slide2.xml><?xml version="1.0" encoding="utf-8"?>
-<p:sld xmlns:a="http://schemas.openxmlformats.org/drawingml/2006/main" xmlns:r="http://schemas.openxmlformats.org/officeDocument/2006/relationships" xmlns:p="http://schemas.openxmlformats.org/presentationml/2006/main">
-  <p:cSld name="Slide 2">
-    <p:bg>
-      <p:bgPr>
-        <a:solidFill>
-          <a:srgbClr val="FFFFFF"/>
-        </a:solidFill>
-        <a:effectLst/>
-      </p:bgPr>
-    </p:bg>
-    <p:spTree>
-      <p:nvGrpSpPr>
-        <p:cNvPr id="1" name=""/>
-        <p:cNvGrpSpPr/>
-        <p:nvPr/>
-      </p:nvGrpSpPr>
-      <p:grpSpPr>
-        <a:xfrm>
-          <a:off x="0" y="0"/>
-          <a:ext cx="0" cy="0"/>
-          <a:chOff x="0" y="0"/>
-          <a:chExt cx="0" cy="0"/>
-        </a:xfrm>
-      </p:grpSpPr>
-      <p:sp>
-        <p:nvSpPr>
-          <p:cNvPr id="2" name="Shape 0"/>
-          <p:cNvSpPr/>
-          <p:nvPr/>
-        </p:nvSpPr>
-        <p:spPr>
-          <a:xfrm>
-            <a:off x="0" y="0"/>
-            <a:ext cx="12191695" cy="502920"/>
-          </a:xfrm>
-          <a:prstGeom prst="rect">
-            <a:avLst/>
-          </a:prstGeom>
-          <a:solidFill>
-            <a:srgbClr val="F8FBFF"/>
-          </a:solidFill>
-          <a:ln w="12700">
-            <a:solidFill>
-              <a:srgbClr val="F8FBFF"/>
-            </a:solidFill>
-            <a:prstDash val="solid"/>
-          </a:ln>
-        </p:spPr>
-        <p:txBody>
-          <a:bodyPr/>
-          <a:lstStyle/>
-          <a:p>
-            <a:endParaRPr lang="en-IN"/>
-          </a:p>
-        </p:txBody>
-      </p:sp>
-      <p:sp>
-        <p:nvSpPr>
-          <p:cNvPr id="3" name="Shape 1"/>
-          <p:cNvSpPr/>
-          <p:nvPr/>
-        </p:nvSpPr>
-        <p:spPr>
-          <a:xfrm>
-            <a:off x="0" y="475488"/>
-            <a:ext cx="12191695" cy="27432"/>
-          </a:xfrm>
-          <a:prstGeom prst="rect">
-            <a:avLst/>
-          </a:prstGeom>
-          <a:solidFill>
-            <a:srgbClr val="2E75B6"/>
-          </a:solidFill>
-          <a:ln w="12700">
-            <a:solidFill>
-              <a:srgbClr val="2E75B6"/>
-            </a:solidFill>
-            <a:prstDash val="solid"/>
-          </a:ln>
-        </p:spPr>
-        <p:txBody>
-          <a:bodyPr/>
-          <a:lstStyle/>
-          <a:p>
-            <a:endParaRPr lang="en-IN"/>
-          </a:p>
-        </p:txBody>
-      </p:sp>
-      <p:sp>
-        <p:nvSpPr>
-          <p:cNvPr id="4" name="Text 2"/>
-          <p:cNvSpPr/>
-          <p:nvPr/>
-        </p:nvSpPr>
-        <p:spPr>
-          <a:xfrm>
-            <a:off x="365760" y="73152"/>
-            <a:ext cx="6400800" cy="274320"/>
-          </a:xfrm>
-          <a:prstGeom prst="rect">
-            <a:avLst/>
-          </a:prstGeom>
-          <a:noFill/>
-          <a:ln/>
-        </p:spPr>
-        <p:txBody>
-          <a:bodyPr wrap="square" lIns="0" tIns="0" rIns="0" bIns="0" rtlCol="0" anchor="ctr"/>
-          <a:lstStyle/>
-          <a:p>
-            <a:pPr marL="0" indent="0">
-              <a:buNone/>
-            </a:pPr>
-            <a:r>
-              <a:rPr lang="en-US" sz="1800" b="1" dirty="0">
-                <a:solidFill>
-                  <a:srgbClr val="1F4E79"/>
-                </a:solidFill>
-                <a:latin typeface="Times New Roman" pitchFamily="34" charset="0"/>
-                <a:ea typeface="Times New Roman" pitchFamily="34" charset="-122"/>
-                <a:cs typeface="Times New Roman" pitchFamily="34" charset="-120"/>
-              </a:rPr>
-              <a:t>TCS349: Responsible and Explainable AI</a:t>
-            </a:r>
-            <a:endParaRPr lang="en-US" sz="1800" dirty="0"/>
-          </a:p>
-        </p:txBody>
-      </p:sp>
-      <p:sp>
-        <p:nvSpPr>
-          <p:cNvPr id="5" name="Text 3"/>
-          <p:cNvSpPr/>
-          <p:nvPr/>
-        </p:nvSpPr>
-        <p:spPr>
-          <a:xfrm>
-            <a:off x="8503920" y="82296"/>
-            <a:ext cx="3200400" cy="274320"/>
-          </a:xfrm>
-          <a:prstGeom prst="rect">
-            <a:avLst/>
-          </a:prstGeom>
-          <a:noFill/>
-          <a:ln/>
-        </p:spPr>
-        <p:txBody>
-          <a:bodyPr wrap="square" lIns="0" tIns="0" rIns="0" bIns="0" rtlCol="0" anchor="ctr"/>
-          <a:lstStyle/>
-          <a:p>
-            <a:pPr marL="0" indent="0" algn="r">
-              <a:buNone/>
-            </a:pPr>
-            <a:r>
-              <a:rPr lang="en-US" sz="1600" b="1" dirty="0">
-                <a:solidFill>
-                  <a:srgbClr val="1F4E79"/>
-                </a:solidFill>
-                <a:latin typeface="Times New Roman" pitchFamily="34" charset="0"/>
-                <a:ea typeface="Times New Roman" pitchFamily="34" charset="-122"/>
-                <a:cs typeface="Times New Roman" pitchFamily="34" charset="-120"/>
-              </a:rPr>
-              <a:t>Unit 1 | Lectures 6 &amp; 7</a:t>
-            </a:r>
-            <a:endParaRPr lang="en-US" sz="1600" dirty="0"/>
-          </a:p>
-        </p:txBody>
-      </p:sp>
-      <p:sp>
-        <p:nvSpPr>
-          <p:cNvPr id="6" name="Text 4"/>
-          <p:cNvSpPr/>
-          <p:nvPr/>
-        </p:nvSpPr>
-        <p:spPr>
-          <a:xfrm>
-            <a:off x="502920" y="658368"/>
-            <a:ext cx="11155680" cy="640080"/>
-          </a:xfrm>
-          <a:prstGeom prst="rect">
-            <a:avLst/>
-          </a:prstGeom>
-          <a:noFill/>
-          <a:ln/>
-        </p:spPr>
-        <p:txBody>
-          <a:bodyPr wrap="square" lIns="0" tIns="0" rIns="0" bIns="0" rtlCol="0" anchor="ctr"/>
-          <a:lstStyle/>
-          <a:p>
-            <a:pPr marL="0" indent="0">
-              <a:buNone/>
-            </a:pPr>
-            <a:r>
-              <a:rPr lang="en-US" sz="2400" b="1" dirty="0">
-                <a:solidFill>
-                  <a:srgbClr val="1F4E79"/>
-                </a:solidFill>
-                <a:latin typeface="Times New Roman" pitchFamily="34" charset="0"/>
-                <a:ea typeface="Times New Roman" pitchFamily="34" charset="-122"/>
-                <a:cs typeface="Times New Roman" pitchFamily="34" charset="-120"/>
-              </a:rPr>
-              <a:t>Where are we in Unit I?</a:t>
-            </a:r>
-            <a:endParaRPr lang="en-US" sz="2400" dirty="0"/>
-          </a:p>
-        </p:txBody>
-      </p:sp>
-      <p:sp>
-        <p:nvSpPr>
-          <p:cNvPr id="7" name="Text 5"/>
-          <p:cNvSpPr/>
-          <p:nvPr/>
-        </p:nvSpPr>
-        <p:spPr>
-          <a:xfrm>
-            <a:off x="594360" y="1463040"/>
-            <a:ext cx="10972800" cy="4297680"/>
-          </a:xfrm>
-          <a:prstGeom prst="rect">
-            <a:avLst/>
-          </a:prstGeom>
-          <a:noFill/>
-          <a:ln/>
-        </p:spPr>
-        <p:txBody>
-          <a:bodyPr wrap="square" lIns="50800" tIns="50800" rIns="50800" bIns="50800" rtlCol="0" anchor="ctr"/>
-          <a:lstStyle/>
-          <a:p>
-            <a:pPr marL="0" indent="0">
-              <a:buNone/>
-            </a:pPr>
-            <a:r>
-              <a:rPr lang="en-US" sz="1700" dirty="0">
-                <a:solidFill>
-                  <a:srgbClr val="191919"/>
-                </a:solidFill>
-                <a:latin typeface="Times New Roman" pitchFamily="34" charset="0"/>
-                <a:ea typeface="Times New Roman" pitchFamily="34" charset="-122"/>
-                <a:cs typeface="Times New Roman" pitchFamily="34" charset="-120"/>
-              </a:rPr>
-              <a:t>Lecture 1: Introduction to AI ethics, Responsible AI and ethical AI development</a:t>
-            </a:r>
-            <a:endParaRPr lang="en-US" sz="1700" dirty="0"/>
-          </a:p>
-          <a:p>
-            <a:pPr marL="0" indent="0">
-              <a:buNone/>
-            </a:pPr>
-            <a:endParaRPr lang="en-US" sz="1700" dirty="0"/>
-          </a:p>
-          <a:p>
-            <a:pPr marL="0" indent="0">
-              <a:buNone/>
-            </a:pPr>
-            <a:r>
-              <a:rPr lang="en-US" sz="1700" dirty="0">
-                <a:solidFill>
-                  <a:srgbClr val="191919"/>
-                </a:solidFill>
-                <a:latin typeface="Times New Roman" pitchFamily="34" charset="0"/>
-                <a:ea typeface="Times New Roman" pitchFamily="34" charset="-122"/>
-                <a:cs typeface="Times New Roman" pitchFamily="34" charset="-120"/>
-              </a:rPr>
-              <a:t>Lecture 2: Ethics, morality, law and fundamental ethical principles</a:t>
-            </a:r>
-            <a:endParaRPr lang="en-US" sz="1700" dirty="0"/>
-          </a:p>
-          <a:p>
-            <a:pPr marL="0" indent="0">
-              <a:buNone/>
-            </a:pPr>
-            <a:endParaRPr lang="en-US" sz="1700" dirty="0"/>
-          </a:p>
-          <a:p>
-            <a:pPr marL="0" indent="0">
-              <a:buNone/>
-            </a:pPr>
-            <a:r>
-              <a:rPr lang="en-US" sz="1700" dirty="0">
-                <a:solidFill>
-                  <a:srgbClr val="191919"/>
-                </a:solidFill>
-                <a:latin typeface="Times New Roman" pitchFamily="34" charset="0"/>
-                <a:ea typeface="Times New Roman" pitchFamily="34" charset="-122"/>
-                <a:cs typeface="Times New Roman" pitchFamily="34" charset="-120"/>
-              </a:rPr>
-              <a:t>Lecture 3: Common ethical dilemmas and stakeholder-oriented ethical analysis</a:t>
-            </a:r>
-            <a:endParaRPr lang="en-US" sz="1700" dirty="0"/>
-          </a:p>
-          <a:p>
-            <a:pPr marL="0" indent="0">
-              <a:buNone/>
-            </a:pPr>
-            <a:endParaRPr lang="en-US" sz="1700" dirty="0"/>
-          </a:p>
-          <a:p>
-            <a:pPr marL="0" indent="0">
-              <a:buNone/>
-            </a:pPr>
-            <a:r>
-              <a:rPr lang="en-US" sz="1700" dirty="0">
-                <a:solidFill>
-                  <a:srgbClr val="191919"/>
-                </a:solidFill>
-                <a:latin typeface="Times New Roman" pitchFamily="34" charset="0"/>
-                <a:ea typeface="Times New Roman" pitchFamily="34" charset="-122"/>
-                <a:cs typeface="Times New Roman" pitchFamily="34" charset="-120"/>
-              </a:rPr>
-              <a:t>Lecture 4: Historical, data, sampling, measurement and label bias</a:t>
-            </a:r>
-            <a:endParaRPr lang="en-US" sz="1700" dirty="0"/>
-          </a:p>
-          <a:p>
-            <a:pPr marL="0" indent="0">
-              <a:buNone/>
-            </a:pPr>
-            <a:endParaRPr lang="en-US" sz="1700" dirty="0"/>
-          </a:p>
-          <a:p>
-            <a:pPr marL="0" indent="0">
-              <a:buNone/>
-            </a:pPr>
-            <a:r>
-              <a:rPr lang="en-US" sz="1700" dirty="0">
-                <a:solidFill>
-                  <a:srgbClr val="191919"/>
-                </a:solidFill>
-                <a:latin typeface="Times New Roman" pitchFamily="34" charset="0"/>
-                <a:ea typeface="Times New Roman" pitchFamily="34" charset="-122"/>
-                <a:cs typeface="Times New Roman" pitchFamily="34" charset="-120"/>
-              </a:rPr>
-              <a:t>Lecture 5: Algorithmic, interactional, feedback-loop and deployment bias</a:t>
-            </a:r>
-            <a:endParaRPr lang="en-US" sz="1700" dirty="0"/>
-          </a:p>
-          <a:p>
-            <a:pPr marL="0" indent="0">
-              <a:buNone/>
-            </a:pPr>
-            <a:endParaRPr lang="en-US" sz="1700" dirty="0"/>
-          </a:p>
-          <a:p>
-            <a:pPr marL="0" indent="0">
-              <a:buNone/>
-            </a:pPr>
-            <a:r>
-              <a:rPr lang="en-US" sz="1700" dirty="0">
-                <a:solidFill>
-                  <a:srgbClr val="191919"/>
-                </a:solidFill>
-                <a:latin typeface="Times New Roman" pitchFamily="34" charset="0"/>
-                <a:ea typeface="Times New Roman" pitchFamily="34" charset="-122"/>
-                <a:cs typeface="Times New Roman" pitchFamily="34" charset="-120"/>
-              </a:rPr>
-              <a:t>Lectures 6 &amp; 7 (Today): Detecting bias with subgroup analysis and confusion-matrix measures; defining group and individual fairness</a:t>
-            </a:r>
-            <a:endParaRPr lang="en-US" sz="1700" dirty="0"/>
-          </a:p>
-        </p:txBody>
-      </p:sp>
-      <p:sp>
-        <p:nvSpPr>
-          <p:cNvPr id="8" name="Text 6"/>
-          <p:cNvSpPr/>
-          <p:nvPr/>
-        </p:nvSpPr>
-        <p:spPr>
-          <a:xfrm>
-            <a:off x="502920" y="5989320"/>
-            <a:ext cx="10744200" cy="411480"/>
-          </a:xfrm>
-          <a:prstGeom prst="rect">
-            <a:avLst/>
-          </a:prstGeom>
-          <a:noFill/>
-          <a:ln/>
-        </p:spPr>
-        <p:txBody>
-          <a:bodyPr wrap="square" lIns="0" tIns="0" rIns="0" bIns="0" rtlCol="0" anchor="ctr"/>
-          <a:lstStyle/>
-          <a:p>
-            <a:pPr marL="0" indent="0">
-              <a:buNone/>
-            </a:pPr>
-            <a:r>
-              <a:rPr lang="en-US" sz="1200" i="1" dirty="0">
-                <a:solidFill>
-                  <a:srgbClr val="595959"/>
-                </a:solidFill>
-                <a:latin typeface="Times New Roman" pitchFamily="34" charset="0"/>
-                <a:ea typeface="Times New Roman" pitchFamily="34" charset="-122"/>
-                <a:cs typeface="Times New Roman" pitchFamily="34" charset="-120"/>
-              </a:rPr>
-              <a:t>Teaching cue: This session spans two lecture slots — pace roughly 20–22 minutes per topic, or split across two class periods as scheduled.</a:t>
-            </a:r>
-            <a:endParaRPr lang="en-US" sz="1200" dirty="0"/>
-          </a:p>
-        </p:txBody>
-      </p:sp>
-      <p:sp>
-        <p:nvSpPr>
-          <p:cNvPr id="9" name="Text 7"/>
-          <p:cNvSpPr/>
-          <p:nvPr/>
-        </p:nvSpPr>
-        <p:spPr>
-          <a:xfrm>
-            <a:off x="11430000" y="6446520"/>
-            <a:ext cx="365760" cy="182880"/>
-          </a:xfrm>
-          <a:prstGeom prst="rect">
-            <a:avLst/>
-          </a:prstGeom>
-          <a:noFill/>
-          <a:ln/>
-        </p:spPr>
-        <p:txBody>
-          <a:bodyPr wrap="square" lIns="0" tIns="0" rIns="0" bIns="0" rtlCol="0" anchor="ctr"/>
-          <a:lstStyle/>
-          <a:p>
-            <a:pPr marL="0" indent="0" algn="ctr">
-              <a:buNone/>
-            </a:pPr>
-            <a:r>
-              <a:rPr lang="en-US" sz="1200" dirty="0">
-                <a:solidFill>
-                  <a:srgbClr val="595959"/>
-                </a:solidFill>
-                <a:latin typeface="Times New Roman" pitchFamily="34" charset="0"/>
-                <a:ea typeface="Times New Roman" pitchFamily="34" charset="-122"/>
-                <a:cs typeface="Times New Roman" pitchFamily="34" charset="-120"/>
-              </a:rPr>
-              <a:t>2</a:t>
-            </a:r>
-            <a:endParaRPr lang="en-US" sz="1200" dirty="0"/>
-          </a:p>
-        </p:txBody>
-      </p:sp>
-    </p:spTree>
-  </p:cSld>
-  <p:clrMapOvr>
-    <a:masterClrMapping/>
-  </p:clrMapOvr>
-</p:sld>
-</file>
-
-<file path=ppt/slides/slide3.xml><?xml version="1.0" encoding="utf-8"?>
-<p:sld xmlns:a="http://schemas.openxmlformats.org/drawingml/2006/main" xmlns:r="http://schemas.openxmlformats.org/officeDocument/2006/relationships" xmlns:p="http://schemas.openxmlformats.org/presentationml/2006/main">
-  <p:cSld name="Slide 3">
-    <p:bg>
-      <p:bgPr>
-        <a:solidFill>
-          <a:srgbClr val="FFFFFF"/>
-        </a:solidFill>
-        <a:effectLst/>
-      </p:bgPr>
-    </p:bg>
-    <p:spTree>
-      <p:nvGrpSpPr>
-        <p:cNvPr id="1" name=""/>
-        <p:cNvGrpSpPr/>
-        <p:nvPr/>
-      </p:nvGrpSpPr>
-      <p:grpSpPr>
-        <a:xfrm>
-          <a:off x="0" y="0"/>
-          <a:ext cx="0" cy="0"/>
-          <a:chOff x="0" y="0"/>
-          <a:chExt cx="0" cy="0"/>
-        </a:xfrm>
-      </p:grpSpPr>
-      <p:sp>
-        <p:nvSpPr>
-          <p:cNvPr id="2" name="Shape 0"/>
-          <p:cNvSpPr/>
-          <p:nvPr/>
-        </p:nvSpPr>
-        <p:spPr>
-          <a:xfrm>
-            <a:off x="0" y="0"/>
-            <a:ext cx="12191695" cy="502920"/>
-          </a:xfrm>
-          <a:prstGeom prst="rect">
-            <a:avLst/>
-          </a:prstGeom>
-          <a:solidFill>
-            <a:srgbClr val="F8FBFF"/>
-          </a:solidFill>
-          <a:ln w="12700">
-            <a:solidFill>
-              <a:srgbClr val="F8FBFF"/>
-            </a:solidFill>
-            <a:prstDash val="solid"/>
-          </a:ln>
-        </p:spPr>
-        <p:txBody>
-          <a:bodyPr/>
-          <a:lstStyle/>
-          <a:p>
-            <a:endParaRPr lang="en-IN"/>
-          </a:p>
-        </p:txBody>
-      </p:sp>
-      <p:sp>
-        <p:nvSpPr>
-          <p:cNvPr id="3" name="Shape 1"/>
-          <p:cNvSpPr/>
-          <p:nvPr/>
-        </p:nvSpPr>
-        <p:spPr>
-          <a:xfrm>
-            <a:off x="0" y="475488"/>
-            <a:ext cx="12191695" cy="27432"/>
-          </a:xfrm>
-          <a:prstGeom prst="rect">
-            <a:avLst/>
-          </a:prstGeom>
-          <a:solidFill>
-            <a:srgbClr val="2E75B6"/>
-          </a:solidFill>
-          <a:ln w="12700">
-            <a:solidFill>
-              <a:srgbClr val="2E75B6"/>
-            </a:solidFill>
-            <a:prstDash val="solid"/>
-          </a:ln>
-        </p:spPr>
-        <p:txBody>
-          <a:bodyPr/>
-          <a:lstStyle/>
-          <a:p>
-            <a:endParaRPr lang="en-IN"/>
-          </a:p>
-        </p:txBody>
-      </p:sp>
-      <p:sp>
-        <p:nvSpPr>
-          <p:cNvPr id="4" name="Text 2"/>
-          <p:cNvSpPr/>
-          <p:nvPr/>
-        </p:nvSpPr>
-        <p:spPr>
-          <a:xfrm>
-            <a:off x="365760" y="73152"/>
-            <a:ext cx="6400800" cy="274320"/>
-          </a:xfrm>
-          <a:prstGeom prst="rect">
-            <a:avLst/>
-          </a:prstGeom>
-          <a:noFill/>
-          <a:ln/>
-        </p:spPr>
-        <p:txBody>
-          <a:bodyPr wrap="square" lIns="0" tIns="0" rIns="0" bIns="0" rtlCol="0" anchor="ctr"/>
-          <a:lstStyle/>
-          <a:p>
-            <a:pPr marL="0" indent="0">
-              <a:buNone/>
-            </a:pPr>
-            <a:r>
-              <a:rPr lang="en-US" sz="1800" b="1" dirty="0">
-                <a:solidFill>
-                  <a:srgbClr val="1F4E79"/>
-                </a:solidFill>
-                <a:latin typeface="Times New Roman" pitchFamily="34" charset="0"/>
-                <a:ea typeface="Times New Roman" pitchFamily="34" charset="-122"/>
-                <a:cs typeface="Times New Roman" pitchFamily="34" charset="-120"/>
-              </a:rPr>
-              <a:t>TCS349: Responsible and Explainable AI</a:t>
-            </a:r>
-            <a:endParaRPr lang="en-US" sz="1800" dirty="0"/>
-          </a:p>
-        </p:txBody>
-      </p:sp>
-      <p:sp>
-        <p:nvSpPr>
-          <p:cNvPr id="5" name="Text 3"/>
-          <p:cNvSpPr/>
-          <p:nvPr/>
-        </p:nvSpPr>
-        <p:spPr>
-          <a:xfrm>
-            <a:off x="8503920" y="82296"/>
-            <a:ext cx="3200400" cy="274320"/>
-          </a:xfrm>
-          <a:prstGeom prst="rect">
-            <a:avLst/>
-          </a:prstGeom>
-          <a:noFill/>
-          <a:ln/>
-        </p:spPr>
-        <p:txBody>
-          <a:bodyPr wrap="square" lIns="0" tIns="0" rIns="0" bIns="0" rtlCol="0" anchor="ctr"/>
-          <a:lstStyle/>
-          <a:p>
-            <a:pPr marL="0" indent="0" algn="r">
-              <a:buNone/>
-            </a:pPr>
-            <a:r>
-              <a:rPr lang="en-US" sz="1600" b="1" dirty="0">
-                <a:solidFill>
-                  <a:srgbClr val="1F4E79"/>
-                </a:solidFill>
-                <a:latin typeface="Times New Roman" pitchFamily="34" charset="0"/>
-                <a:ea typeface="Times New Roman" pitchFamily="34" charset="-122"/>
-                <a:cs typeface="Times New Roman" pitchFamily="34" charset="-120"/>
-              </a:rPr>
-              <a:t>Unit 1 | Lectures 6 &amp; 7</a:t>
-            </a:r>
-            <a:endParaRPr lang="en-US" sz="1600" dirty="0"/>
-          </a:p>
-        </p:txBody>
-      </p:sp>
-      <p:sp>
-        <p:nvSpPr>
-          <p:cNvPr id="6" name="Text 4"/>
-          <p:cNvSpPr/>
-          <p:nvPr/>
-        </p:nvSpPr>
-        <p:spPr>
-          <a:xfrm>
-            <a:off x="502920" y="658368"/>
-            <a:ext cx="11155680" cy="640080"/>
-          </a:xfrm>
-          <a:prstGeom prst="rect">
-            <a:avLst/>
-          </a:prstGeom>
-          <a:noFill/>
-          <a:ln/>
-        </p:spPr>
-        <p:txBody>
-          <a:bodyPr wrap="square" lIns="0" tIns="0" rIns="0" bIns="0" rtlCol="0" anchor="ctr"/>
-          <a:lstStyle/>
-          <a:p>
-            <a:pPr marL="0" indent="0">
-              <a:buNone/>
-            </a:pPr>
-            <a:r>
-              <a:rPr lang="en-US" sz="2400" b="1" dirty="0">
-                <a:solidFill>
-                  <a:srgbClr val="1F4E79"/>
-                </a:solidFill>
-                <a:latin typeface="Times New Roman" pitchFamily="34" charset="0"/>
-                <a:ea typeface="Times New Roman" pitchFamily="34" charset="-122"/>
-                <a:cs typeface="Times New Roman" pitchFamily="34" charset="-120"/>
-              </a:rPr>
-              <a:t>Lecture Outcomes</a:t>
-            </a:r>
-            <a:endParaRPr lang="en-US" sz="2400" dirty="0"/>
-          </a:p>
-        </p:txBody>
-      </p:sp>
-      <p:sp>
-        <p:nvSpPr>
-          <p:cNvPr id="7" name="Text 5"/>
-          <p:cNvSpPr/>
-          <p:nvPr/>
-        </p:nvSpPr>
-        <p:spPr>
-          <a:xfrm>
-            <a:off x="594360" y="1463040"/>
-            <a:ext cx="10972800" cy="4206240"/>
-          </a:xfrm>
-          <a:prstGeom prst="rect">
-            <a:avLst/>
-          </a:prstGeom>
-          <a:noFill/>
-          <a:ln/>
-        </p:spPr>
-        <p:txBody>
-          <a:bodyPr wrap="square" lIns="50800" tIns="50800" rIns="50800" bIns="50800" rtlCol="0" anchor="ctr"/>
-          <a:lstStyle/>
-          <a:p>
-            <a:pPr marL="0" indent="0">
-              <a:buNone/>
-            </a:pPr>
-            <a:r>
-              <a:rPr lang="en-US" sz="1800" dirty="0">
-                <a:solidFill>
-                  <a:srgbClr val="191919"/>
-                </a:solidFill>
-                <a:latin typeface="Times New Roman" pitchFamily="34" charset="0"/>
-                <a:ea typeface="Times New Roman" pitchFamily="34" charset="-122"/>
-                <a:cs typeface="Times New Roman" pitchFamily="34" charset="-120"/>
-              </a:rPr>
-              <a:t>Perform subgroup analysis to detect performance gaps hidden by overall accuracy.</a:t>
-            </a:r>
-            <a:endParaRPr lang="en-US" sz="1800" dirty="0"/>
-          </a:p>
-          <a:p>
-            <a:pPr marL="0" indent="0">
-              <a:buNone/>
-            </a:pPr>
-            <a:endParaRPr lang="en-US" sz="1800" dirty="0"/>
-          </a:p>
-          <a:p>
-            <a:pPr marL="0" indent="0">
-              <a:buNone/>
-            </a:pPr>
-            <a:r>
-              <a:rPr lang="en-US" sz="1800" dirty="0">
-                <a:solidFill>
-                  <a:srgbClr val="191919"/>
-                </a:solidFill>
-                <a:latin typeface="Times New Roman" pitchFamily="34" charset="0"/>
-                <a:ea typeface="Times New Roman" pitchFamily="34" charset="-122"/>
-                <a:cs typeface="Times New Roman" pitchFamily="34" charset="-120"/>
-              </a:rPr>
-              <a:t>Compute confusion-matrix-based measures — TPR, FPR and FNR — for each subgroup.</a:t>
-            </a:r>
-            <a:endParaRPr lang="en-US" sz="1800" dirty="0"/>
-          </a:p>
-          <a:p>
-            <a:pPr marL="0" indent="0">
-              <a:buNone/>
-            </a:pPr>
-            <a:endParaRPr lang="en-US" sz="1800" dirty="0"/>
-          </a:p>
-          <a:p>
-            <a:pPr marL="0" indent="0">
-              <a:buNone/>
-            </a:pPr>
-            <a:r>
-              <a:rPr lang="en-US" sz="1800" dirty="0">
-                <a:solidFill>
-                  <a:srgbClr val="191919"/>
-                </a:solidFill>
-                <a:latin typeface="Times New Roman" pitchFamily="34" charset="0"/>
-                <a:ea typeface="Times New Roman" pitchFamily="34" charset="-122"/>
-                <a:cs typeface="Times New Roman" pitchFamily="34" charset="-120"/>
-              </a:rPr>
-              <a:t>Interpret numerical evidence of bias using a worked example.</a:t>
-            </a:r>
-            <a:endParaRPr lang="en-US" sz="1800" dirty="0"/>
-          </a:p>
-          <a:p>
-            <a:pPr marL="0" indent="0">
-              <a:buNone/>
-            </a:pPr>
-            <a:endParaRPr lang="en-US" sz="1800" dirty="0"/>
-          </a:p>
-          <a:p>
-            <a:pPr marL="0" indent="0">
-              <a:buNone/>
-            </a:pPr>
-            <a:r>
-              <a:rPr lang="en-US" sz="1800" dirty="0">
-                <a:solidFill>
-                  <a:srgbClr val="191919"/>
-                </a:solidFill>
-                <a:latin typeface="Times New Roman" pitchFamily="34" charset="0"/>
-                <a:ea typeface="Times New Roman" pitchFamily="34" charset="-122"/>
-                <a:cs typeface="Times New Roman" pitchFamily="34" charset="-120"/>
-              </a:rPr>
-              <a:t>Define group fairness (demographic parity, equal opportunity, equalized odds) and individual fairness.</a:t>
-            </a:r>
-            <a:endParaRPr lang="en-US" sz="1800" dirty="0"/>
-          </a:p>
-          <a:p>
-            <a:pPr marL="0" indent="0">
-              <a:buNone/>
-            </a:pPr>
-            <a:endParaRPr lang="en-US" sz="1800" dirty="0"/>
-          </a:p>
-          <a:p>
-            <a:pPr marL="0" indent="0">
-              <a:buNone/>
-            </a:pPr>
-            <a:r>
-              <a:rPr lang="en-US" sz="1800" dirty="0">
-                <a:solidFill>
-                  <a:srgbClr val="191919"/>
-                </a:solidFill>
-                <a:latin typeface="Times New Roman" pitchFamily="34" charset="0"/>
-                <a:ea typeface="Times New Roman" pitchFamily="34" charset="-122"/>
-                <a:cs typeface="Times New Roman" pitchFamily="34" charset="-120"/>
-              </a:rPr>
-              <a:t>Compare fairness notions and recognise the trade-offs between them.</a:t>
-            </a:r>
-            <a:endParaRPr lang="en-US" sz="1800" dirty="0"/>
-          </a:p>
-        </p:txBody>
-      </p:sp>
-      <p:sp>
-        <p:nvSpPr>
-          <p:cNvPr id="8" name="Text 6"/>
-          <p:cNvSpPr/>
-          <p:nvPr/>
-        </p:nvSpPr>
-        <p:spPr>
-          <a:xfrm>
-            <a:off x="502920" y="5989320"/>
-            <a:ext cx="10744200" cy="411480"/>
-          </a:xfrm>
-          <a:prstGeom prst="rect">
-            <a:avLst/>
-          </a:prstGeom>
-          <a:noFill/>
-          <a:ln/>
-        </p:spPr>
-        <p:txBody>
-          <a:bodyPr wrap="square" lIns="0" tIns="0" rIns="0" bIns="0" rtlCol="0" anchor="ctr"/>
-          <a:lstStyle/>
-          <a:p>
-            <a:pPr marL="0" indent="0">
-              <a:buNone/>
-            </a:pPr>
-            <a:r>
-              <a:rPr lang="en-US" sz="1200" i="1" dirty="0">
-                <a:solidFill>
-                  <a:srgbClr val="595959"/>
-                </a:solidFill>
-                <a:latin typeface="Times New Roman" pitchFamily="34" charset="0"/>
-                <a:ea typeface="Times New Roman" pitchFamily="34" charset="-122"/>
-                <a:cs typeface="Times New Roman" pitchFamily="34" charset="-120"/>
-              </a:rPr>
-              <a:t>Teaching cue: Emphasise that detection (Lecture 6) motivates the formal fairness definitions (Lecture 7) — one leads into the other.</a:t>
-            </a:r>
-            <a:endParaRPr lang="en-US" sz="1200" dirty="0"/>
-          </a:p>
-        </p:txBody>
-      </p:sp>
-      <p:sp>
-        <p:nvSpPr>
-          <p:cNvPr id="9" name="Text 7"/>
-          <p:cNvSpPr/>
-          <p:nvPr/>
-        </p:nvSpPr>
-        <p:spPr>
-          <a:xfrm>
-            <a:off x="11430000" y="6446520"/>
-            <a:ext cx="365760" cy="182880"/>
-          </a:xfrm>
-          <a:prstGeom prst="rect">
-            <a:avLst/>
-          </a:prstGeom>
-          <a:noFill/>
-          <a:ln/>
-        </p:spPr>
-        <p:txBody>
-          <a:bodyPr wrap="square" lIns="0" tIns="0" rIns="0" bIns="0" rtlCol="0" anchor="ctr"/>
-          <a:lstStyle/>
-          <a:p>
-            <a:pPr marL="0" indent="0" algn="ctr">
-              <a:buNone/>
-            </a:pPr>
-            <a:r>
-              <a:rPr lang="en-US" sz="1200" dirty="0">
-                <a:solidFill>
-                  <a:srgbClr val="595959"/>
-                </a:solidFill>
-                <a:latin typeface="Times New Roman" pitchFamily="34" charset="0"/>
-                <a:ea typeface="Times New Roman" pitchFamily="34" charset="-122"/>
-                <a:cs typeface="Times New Roman" pitchFamily="34" charset="-120"/>
-              </a:rPr>
-              <a:t>3</a:t>
-            </a:r>
-            <a:endParaRPr lang="en-US" sz="1200" dirty="0"/>
-          </a:p>
-        </p:txBody>
-      </p:sp>
-    </p:spTree>
-  </p:cSld>
-  <p:clrMapOvr>
-    <a:masterClrMapping/>
-  </p:clrMapOvr>
-</p:sld>
-</file>
-
-<file path=ppt/slides/slide4.xml><?xml version="1.0" encoding="utf-8"?>
 <p:sld xmlns:a="http://schemas.openxmlformats.org/drawingml/2006/main" xmlns:r="http://schemas.openxmlformats.org/officeDocument/2006/relationships" xmlns:p="http://schemas.openxmlformats.org/presentationml/2006/main">
   <p:cSld name="Slide 4">
     <p:bg>
@@ -9019,45 +5918,6 @@
       </p:sp>
       <p:sp>
         <p:nvSpPr>
-          <p:cNvPr id="8" name="Text 6"/>
-          <p:cNvSpPr/>
-          <p:nvPr/>
-        </p:nvSpPr>
-        <p:spPr>
-          <a:xfrm>
-            <a:off x="502920" y="5989320"/>
-            <a:ext cx="10744200" cy="411480"/>
-          </a:xfrm>
-          <a:prstGeom prst="rect">
-            <a:avLst/>
-          </a:prstGeom>
-          <a:noFill/>
-          <a:ln/>
-        </p:spPr>
-        <p:txBody>
-          <a:bodyPr wrap="square" lIns="0" tIns="0" rIns="0" bIns="0" rtlCol="0" anchor="ctr"/>
-          <a:lstStyle/>
-          <a:p>
-            <a:pPr marL="0" indent="0">
-              <a:buNone/>
-            </a:pPr>
-            <a:r>
-              <a:rPr lang="en-US" sz="1200" i="1" dirty="0">
-                <a:solidFill>
-                  <a:srgbClr val="595959"/>
-                </a:solidFill>
-                <a:latin typeface="Times New Roman" pitchFamily="34" charset="0"/>
-                <a:ea typeface="Times New Roman" pitchFamily="34" charset="-122"/>
-                <a:cs typeface="Times New Roman" pitchFamily="34" charset="-120"/>
-              </a:rPr>
-              <a:t>Teaching cue: Contrast one aggregate accuracy figure with subgroup-wise accuracy to show how averages can hide bias.</a:t>
-            </a:r>
-            <a:endParaRPr lang="en-US" sz="1200" dirty="0"/>
-          </a:p>
-        </p:txBody>
-      </p:sp>
-      <p:sp>
-        <p:nvSpPr>
           <p:cNvPr id="9" name="Text 7"/>
           <p:cNvSpPr/>
           <p:nvPr/>
@@ -9103,7 +5963,7 @@
 </p:sld>
 </file>
 
-<file path=ppt/slides/slide5.xml><?xml version="1.0" encoding="utf-8"?>
+<file path=ppt/slides/slide3.xml><?xml version="1.0" encoding="utf-8"?>
 <p:sld xmlns:a="http://schemas.openxmlformats.org/drawingml/2006/main" xmlns:r="http://schemas.openxmlformats.org/officeDocument/2006/relationships" xmlns:p="http://schemas.openxmlformats.org/presentationml/2006/main">
   <p:cSld name="Slide 5">
     <p:bg>
@@ -10032,45 +6892,6 @@
       </p:graphicFrame>
       <p:sp>
         <p:nvSpPr>
-          <p:cNvPr id="9" name="Text 6"/>
-          <p:cNvSpPr/>
-          <p:nvPr/>
-        </p:nvSpPr>
-        <p:spPr>
-          <a:xfrm>
-            <a:off x="502920" y="5989320"/>
-            <a:ext cx="10744200" cy="411480"/>
-          </a:xfrm>
-          <a:prstGeom prst="rect">
-            <a:avLst/>
-          </a:prstGeom>
-          <a:noFill/>
-          <a:ln/>
-        </p:spPr>
-        <p:txBody>
-          <a:bodyPr wrap="square" lIns="0" tIns="0" rIns="0" bIns="0" rtlCol="0" anchor="ctr"/>
-          <a:lstStyle/>
-          <a:p>
-            <a:pPr marL="0" indent="0">
-              <a:buNone/>
-            </a:pPr>
-            <a:r>
-              <a:rPr lang="en-US" sz="1200" i="1" dirty="0">
-                <a:solidFill>
-                  <a:srgbClr val="595959"/>
-                </a:solidFill>
-                <a:latin typeface="Times New Roman" pitchFamily="34" charset="0"/>
-                <a:ea typeface="Times New Roman" pitchFamily="34" charset="-122"/>
-                <a:cs typeface="Times New Roman" pitchFamily="34" charset="-120"/>
-              </a:rPr>
-              <a:t>Teaching cue: Draw the 2x2 confusion matrix on the board before introducing its subgroup-wise version.</a:t>
-            </a:r>
-            <a:endParaRPr lang="en-US" sz="1200" dirty="0"/>
-          </a:p>
-        </p:txBody>
-      </p:sp>
-      <p:sp>
-        <p:nvSpPr>
           <p:cNvPr id="10" name="Text 7"/>
           <p:cNvSpPr/>
           <p:nvPr/>
@@ -10116,7 +6937,7 @@
 </p:sld>
 </file>
 
-<file path=ppt/slides/slide6.xml><?xml version="1.0" encoding="utf-8"?>
+<file path=ppt/slides/slide4.xml><?xml version="1.0" encoding="utf-8"?>
 <p:sld xmlns:a="http://schemas.openxmlformats.org/drawingml/2006/main" xmlns:r="http://schemas.openxmlformats.org/officeDocument/2006/relationships" xmlns:p="http://schemas.openxmlformats.org/presentationml/2006/main">
   <p:cSld name="Slide 6">
     <p:bg>
@@ -10432,45 +7253,6 @@
       </p:sp>
       <p:sp>
         <p:nvSpPr>
-          <p:cNvPr id="8" name="Text 6"/>
-          <p:cNvSpPr/>
-          <p:nvPr/>
-        </p:nvSpPr>
-        <p:spPr>
-          <a:xfrm>
-            <a:off x="502920" y="5989320"/>
-            <a:ext cx="10744200" cy="411480"/>
-          </a:xfrm>
-          <a:prstGeom prst="rect">
-            <a:avLst/>
-          </a:prstGeom>
-          <a:noFill/>
-          <a:ln/>
-        </p:spPr>
-        <p:txBody>
-          <a:bodyPr wrap="square" lIns="0" tIns="0" rIns="0" bIns="0" rtlCol="0" anchor="ctr"/>
-          <a:lstStyle/>
-          <a:p>
-            <a:pPr marL="0" indent="0">
-              <a:buNone/>
-            </a:pPr>
-            <a:r>
-              <a:rPr lang="en-US" sz="1200" i="1" dirty="0">
-                <a:solidFill>
-                  <a:srgbClr val="595959"/>
-                </a:solidFill>
-                <a:latin typeface="Times New Roman" pitchFamily="34" charset="0"/>
-                <a:ea typeface="Times New Roman" pitchFamily="34" charset="-122"/>
-                <a:cs typeface="Times New Roman" pitchFamily="34" charset="-120"/>
-              </a:rPr>
-              <a:t>Teaching cue: Ask which rate matters most in a given application — e.g., FNR is critical in medical screening.</a:t>
-            </a:r>
-            <a:endParaRPr lang="en-US" sz="1200" dirty="0"/>
-          </a:p>
-        </p:txBody>
-      </p:sp>
-      <p:sp>
-        <p:nvSpPr>
           <p:cNvPr id="9" name="Text 7"/>
           <p:cNvSpPr/>
           <p:nvPr/>
@@ -10516,7 +7298,7 @@
 </p:sld>
 </file>
 
-<file path=ppt/slides/slide7.xml><?xml version="1.0" encoding="utf-8"?>
+<file path=ppt/slides/slide5.xml><?xml version="1.0" encoding="utf-8"?>
 <p:sld xmlns:a="http://schemas.openxmlformats.org/drawingml/2006/main" xmlns:r="http://schemas.openxmlformats.org/officeDocument/2006/relationships" xmlns:p="http://schemas.openxmlformats.org/presentationml/2006/main">
   <p:cSld name="Slide 7">
     <p:bg>
@@ -12289,45 +9071,6 @@
       </p:graphicFrame>
       <p:sp>
         <p:nvSpPr>
-          <p:cNvPr id="9" name="Text 6"/>
-          <p:cNvSpPr/>
-          <p:nvPr/>
-        </p:nvSpPr>
-        <p:spPr>
-          <a:xfrm>
-            <a:off x="502920" y="5989320"/>
-            <a:ext cx="10744200" cy="411480"/>
-          </a:xfrm>
-          <a:prstGeom prst="rect">
-            <a:avLst/>
-          </a:prstGeom>
-          <a:noFill/>
-          <a:ln/>
-        </p:spPr>
-        <p:txBody>
-          <a:bodyPr wrap="square" lIns="0" tIns="0" rIns="0" bIns="0" rtlCol="0" anchor="ctr"/>
-          <a:lstStyle/>
-          <a:p>
-            <a:pPr marL="0" indent="0">
-              <a:buNone/>
-            </a:pPr>
-            <a:r>
-              <a:rPr lang="en-US" sz="1200" i="1" dirty="0">
-                <a:solidFill>
-                  <a:srgbClr val="595959"/>
-                </a:solidFill>
-                <a:latin typeface="Times New Roman" pitchFamily="34" charset="0"/>
-                <a:ea typeface="Times New Roman" pitchFamily="34" charset="-122"/>
-                <a:cs typeface="Times New Roman" pitchFamily="34" charset="-120"/>
-              </a:rPr>
-              <a:t>Teaching cue: Keep the numbers simple and round so students can verify each calculation in class.</a:t>
-            </a:r>
-            <a:endParaRPr lang="en-US" sz="1200" dirty="0"/>
-          </a:p>
-        </p:txBody>
-      </p:sp>
-      <p:sp>
-        <p:nvSpPr>
           <p:cNvPr id="10" name="Text 7"/>
           <p:cNvSpPr/>
           <p:nvPr/>
@@ -12373,7 +9116,7 @@
 </p:sld>
 </file>
 
-<file path=ppt/slides/slide8.xml><?xml version="1.0" encoding="utf-8"?>
+<file path=ppt/slides/slide6.xml><?xml version="1.0" encoding="utf-8"?>
 <p:sld xmlns:a="http://schemas.openxmlformats.org/drawingml/2006/main" xmlns:r="http://schemas.openxmlformats.org/officeDocument/2006/relationships" xmlns:p="http://schemas.openxmlformats.org/presentationml/2006/main">
   <p:cSld name="Slide 8">
     <p:bg>
@@ -15369,7 +12112,7 @@
 </p:sld>
 </file>
 
-<file path=ppt/slides/slide9.xml><?xml version="1.0" encoding="utf-8"?>
+<file path=ppt/slides/slide7.xml><?xml version="1.0" encoding="utf-8"?>
 <p:sld xmlns:a="http://schemas.openxmlformats.org/drawingml/2006/main" xmlns:r="http://schemas.openxmlformats.org/officeDocument/2006/relationships" xmlns:p="http://schemas.openxmlformats.org/presentationml/2006/main">
   <p:cSld name="Slide 9">
     <p:bg>
@@ -15685,45 +12428,6 @@
       </p:sp>
       <p:sp>
         <p:nvSpPr>
-          <p:cNvPr id="8" name="Text 6"/>
-          <p:cNvSpPr/>
-          <p:nvPr/>
-        </p:nvSpPr>
-        <p:spPr>
-          <a:xfrm>
-            <a:off x="502920" y="5989320"/>
-            <a:ext cx="10744200" cy="411480"/>
-          </a:xfrm>
-          <a:prstGeom prst="rect">
-            <a:avLst/>
-          </a:prstGeom>
-          <a:noFill/>
-          <a:ln/>
-        </p:spPr>
-        <p:txBody>
-          <a:bodyPr wrap="square" lIns="0" tIns="0" rIns="0" bIns="0" rtlCol="0" anchor="ctr"/>
-          <a:lstStyle/>
-          <a:p>
-            <a:pPr marL="0" indent="0">
-              <a:buNone/>
-            </a:pPr>
-            <a:r>
-              <a:rPr lang="en-US" sz="1200" i="1" dirty="0">
-                <a:solidFill>
-                  <a:srgbClr val="595959"/>
-                </a:solidFill>
-                <a:latin typeface="Times New Roman" pitchFamily="34" charset="0"/>
-                <a:ea typeface="Times New Roman" pitchFamily="34" charset="-122"/>
-                <a:cs typeface="Times New Roman" pitchFamily="34" charset="-120"/>
-              </a:rPr>
-              <a:t>Teaching cue: This slide is the pivot point of the session — bias detection leads directly into the fairness definitions next.</a:t>
-            </a:r>
-            <a:endParaRPr lang="en-US" sz="1200" dirty="0"/>
-          </a:p>
-        </p:txBody>
-      </p:sp>
-      <p:sp>
-        <p:nvSpPr>
           <p:cNvPr id="9" name="Text 7"/>
           <p:cNvSpPr/>
           <p:nvPr/>
@@ -15756,6 +12460,728 @@
                 <a:cs typeface="Times New Roman" pitchFamily="34" charset="-120"/>
               </a:rPr>
               <a:t>9</a:t>
+            </a:r>
+            <a:endParaRPr lang="en-US" sz="1200" dirty="0"/>
+          </a:p>
+        </p:txBody>
+      </p:sp>
+    </p:spTree>
+  </p:cSld>
+  <p:clrMapOvr>
+    <a:masterClrMapping/>
+  </p:clrMapOvr>
+</p:sld>
+</file>
+
+<file path=ppt/slides/slide8.xml><?xml version="1.0" encoding="utf-8"?>
+<p:sld xmlns:a="http://schemas.openxmlformats.org/drawingml/2006/main" xmlns:r="http://schemas.openxmlformats.org/officeDocument/2006/relationships" xmlns:p="http://schemas.openxmlformats.org/presentationml/2006/main">
+  <p:cSld name="Slide 10">
+    <p:bg>
+      <p:bgPr>
+        <a:solidFill>
+          <a:srgbClr val="FFFFFF"/>
+        </a:solidFill>
+        <a:effectLst/>
+      </p:bgPr>
+    </p:bg>
+    <p:spTree>
+      <p:nvGrpSpPr>
+        <p:cNvPr id="1" name=""/>
+        <p:cNvGrpSpPr/>
+        <p:nvPr/>
+      </p:nvGrpSpPr>
+      <p:grpSpPr>
+        <a:xfrm>
+          <a:off x="0" y="0"/>
+          <a:ext cx="0" cy="0"/>
+          <a:chOff x="0" y="0"/>
+          <a:chExt cx="0" cy="0"/>
+        </a:xfrm>
+      </p:grpSpPr>
+      <p:sp>
+        <p:nvSpPr>
+          <p:cNvPr id="2" name="Shape 0"/>
+          <p:cNvSpPr/>
+          <p:nvPr/>
+        </p:nvSpPr>
+        <p:spPr>
+          <a:xfrm>
+            <a:off x="0" y="0"/>
+            <a:ext cx="12191695" cy="502920"/>
+          </a:xfrm>
+          <a:prstGeom prst="rect">
+            <a:avLst/>
+          </a:prstGeom>
+          <a:solidFill>
+            <a:srgbClr val="F8FBFF"/>
+          </a:solidFill>
+          <a:ln w="12700">
+            <a:solidFill>
+              <a:srgbClr val="F8FBFF"/>
+            </a:solidFill>
+            <a:prstDash val="solid"/>
+          </a:ln>
+        </p:spPr>
+        <p:txBody>
+          <a:bodyPr/>
+          <a:lstStyle/>
+          <a:p>
+            <a:endParaRPr lang="en-IN"/>
+          </a:p>
+        </p:txBody>
+      </p:sp>
+      <p:sp>
+        <p:nvSpPr>
+          <p:cNvPr id="3" name="Shape 1"/>
+          <p:cNvSpPr/>
+          <p:nvPr/>
+        </p:nvSpPr>
+        <p:spPr>
+          <a:xfrm>
+            <a:off x="0" y="475488"/>
+            <a:ext cx="12191695" cy="27432"/>
+          </a:xfrm>
+          <a:prstGeom prst="rect">
+            <a:avLst/>
+          </a:prstGeom>
+          <a:solidFill>
+            <a:srgbClr val="2E75B6"/>
+          </a:solidFill>
+          <a:ln w="12700">
+            <a:solidFill>
+              <a:srgbClr val="2E75B6"/>
+            </a:solidFill>
+            <a:prstDash val="solid"/>
+          </a:ln>
+        </p:spPr>
+        <p:txBody>
+          <a:bodyPr/>
+          <a:lstStyle/>
+          <a:p>
+            <a:endParaRPr lang="en-IN"/>
+          </a:p>
+        </p:txBody>
+      </p:sp>
+      <p:sp>
+        <p:nvSpPr>
+          <p:cNvPr id="4" name="Text 2"/>
+          <p:cNvSpPr/>
+          <p:nvPr/>
+        </p:nvSpPr>
+        <p:spPr>
+          <a:xfrm>
+            <a:off x="365760" y="73152"/>
+            <a:ext cx="6400800" cy="274320"/>
+          </a:xfrm>
+          <a:prstGeom prst="rect">
+            <a:avLst/>
+          </a:prstGeom>
+          <a:noFill/>
+          <a:ln/>
+        </p:spPr>
+        <p:txBody>
+          <a:bodyPr wrap="square" lIns="0" tIns="0" rIns="0" bIns="0" rtlCol="0" anchor="ctr"/>
+          <a:lstStyle/>
+          <a:p>
+            <a:pPr marL="0" indent="0">
+              <a:buNone/>
+            </a:pPr>
+            <a:r>
+              <a:rPr lang="en-US" sz="1800" b="1" dirty="0">
+                <a:solidFill>
+                  <a:srgbClr val="1F4E79"/>
+                </a:solidFill>
+                <a:latin typeface="Times New Roman" pitchFamily="34" charset="0"/>
+                <a:ea typeface="Times New Roman" pitchFamily="34" charset="-122"/>
+                <a:cs typeface="Times New Roman" pitchFamily="34" charset="-120"/>
+              </a:rPr>
+              <a:t>TCS349: Responsible and Explainable AI</a:t>
+            </a:r>
+            <a:endParaRPr lang="en-US" sz="1800" dirty="0"/>
+          </a:p>
+        </p:txBody>
+      </p:sp>
+      <p:sp>
+        <p:nvSpPr>
+          <p:cNvPr id="5" name="Text 3"/>
+          <p:cNvSpPr/>
+          <p:nvPr/>
+        </p:nvSpPr>
+        <p:spPr>
+          <a:xfrm>
+            <a:off x="8503920" y="82296"/>
+            <a:ext cx="3200400" cy="274320"/>
+          </a:xfrm>
+          <a:prstGeom prst="rect">
+            <a:avLst/>
+          </a:prstGeom>
+          <a:noFill/>
+          <a:ln/>
+        </p:spPr>
+        <p:txBody>
+          <a:bodyPr wrap="square" lIns="0" tIns="0" rIns="0" bIns="0" rtlCol="0" anchor="ctr"/>
+          <a:lstStyle/>
+          <a:p>
+            <a:pPr marL="0" indent="0" algn="r">
+              <a:buNone/>
+            </a:pPr>
+            <a:r>
+              <a:rPr lang="en-US" sz="1600" b="1" dirty="0">
+                <a:solidFill>
+                  <a:srgbClr val="1F4E79"/>
+                </a:solidFill>
+                <a:latin typeface="Times New Roman" pitchFamily="34" charset="0"/>
+                <a:ea typeface="Times New Roman" pitchFamily="34" charset="-122"/>
+                <a:cs typeface="Times New Roman" pitchFamily="34" charset="-120"/>
+              </a:rPr>
+              <a:t>Unit 1 | Lecture 6</a:t>
+            </a:r>
+            <a:endParaRPr lang="en-US" sz="1600" dirty="0"/>
+          </a:p>
+        </p:txBody>
+      </p:sp>
+      <p:sp>
+        <p:nvSpPr>
+          <p:cNvPr id="6" name="Text 4"/>
+          <p:cNvSpPr/>
+          <p:nvPr/>
+        </p:nvSpPr>
+        <p:spPr>
+          <a:xfrm>
+            <a:off x="502920" y="658368"/>
+            <a:ext cx="11155680" cy="640080"/>
+          </a:xfrm>
+          <a:prstGeom prst="rect">
+            <a:avLst/>
+          </a:prstGeom>
+          <a:noFill/>
+          <a:ln/>
+        </p:spPr>
+        <p:txBody>
+          <a:bodyPr wrap="square" lIns="0" tIns="0" rIns="0" bIns="0" rtlCol="0" anchor="ctr"/>
+          <a:lstStyle/>
+          <a:p>
+            <a:pPr marL="0" indent="0">
+              <a:buNone/>
+            </a:pPr>
+            <a:r>
+              <a:rPr lang="en-US" sz="2400" b="1" dirty="0">
+                <a:solidFill>
+                  <a:srgbClr val="1F4E79"/>
+                </a:solidFill>
+                <a:latin typeface="Times New Roman" pitchFamily="34" charset="0"/>
+                <a:ea typeface="Times New Roman" pitchFamily="34" charset="-122"/>
+                <a:cs typeface="Times New Roman" pitchFamily="34" charset="-120"/>
+              </a:rPr>
+              <a:t>7. Tools for Bias Detection</a:t>
+            </a:r>
+            <a:endParaRPr lang="en-US" sz="2400" dirty="0"/>
+          </a:p>
+        </p:txBody>
+      </p:sp>
+      <p:sp>
+        <p:nvSpPr>
+          <p:cNvPr id="7" name="Text 5"/>
+          <p:cNvSpPr/>
+          <p:nvPr/>
+        </p:nvSpPr>
+        <p:spPr>
+          <a:xfrm>
+            <a:off x="594360" y="1463040"/>
+            <a:ext cx="10972800" cy="4206240"/>
+          </a:xfrm>
+          <a:prstGeom prst="rect">
+            <a:avLst/>
+          </a:prstGeom>
+          <a:noFill/>
+          <a:ln/>
+        </p:spPr>
+        <p:txBody>
+          <a:bodyPr wrap="square" lIns="50800" tIns="50800" rIns="50800" bIns="50800" rtlCol="0" anchor="ctr"/>
+          <a:lstStyle/>
+          <a:p>
+            <a:pPr marL="0" indent="0">
+              <a:buNone/>
+            </a:pPr>
+            <a:r>
+              <a:rPr lang="en-US" sz="1800" dirty="0">
+                <a:solidFill>
+                  <a:srgbClr val="191919"/>
+                </a:solidFill>
+                <a:latin typeface="Times New Roman" pitchFamily="34" charset="0"/>
+                <a:ea typeface="Times New Roman" pitchFamily="34" charset="-122"/>
+                <a:cs typeface="Times New Roman" pitchFamily="34" charset="-120"/>
+              </a:rPr>
+              <a:t>Fairlearn (Microsoft): a Python library for assessing and mitigating fairness issues in ML models.</a:t>
+            </a:r>
+            <a:endParaRPr lang="en-US" sz="1800" dirty="0"/>
+          </a:p>
+          <a:p>
+            <a:pPr marL="0" indent="0">
+              <a:buNone/>
+            </a:pPr>
+            <a:endParaRPr lang="en-US" sz="1800" dirty="0"/>
+          </a:p>
+          <a:p>
+            <a:pPr marL="0" indent="0">
+              <a:buNone/>
+            </a:pPr>
+            <a:r>
+              <a:rPr lang="en-US" sz="1800" dirty="0">
+                <a:solidFill>
+                  <a:srgbClr val="191919"/>
+                </a:solidFill>
+                <a:latin typeface="Times New Roman" pitchFamily="34" charset="0"/>
+                <a:ea typeface="Times New Roman" pitchFamily="34" charset="-122"/>
+                <a:cs typeface="Times New Roman" pitchFamily="34" charset="-120"/>
+              </a:rPr>
+              <a:t>IBM AI Fairness 360 (AIF360): an open-source toolkit offering 70+ fairness metrics and bias-mitigation algorithms.</a:t>
+            </a:r>
+            <a:endParaRPr lang="en-US" sz="1800" dirty="0"/>
+          </a:p>
+          <a:p>
+            <a:pPr marL="0" indent="0">
+              <a:buNone/>
+            </a:pPr>
+            <a:endParaRPr lang="en-US" sz="1800" dirty="0"/>
+          </a:p>
+          <a:p>
+            <a:pPr marL="0" indent="0">
+              <a:buNone/>
+            </a:pPr>
+            <a:r>
+              <a:rPr lang="en-US" sz="1800" dirty="0">
+                <a:solidFill>
+                  <a:srgbClr val="191919"/>
+                </a:solidFill>
+                <a:latin typeface="Times New Roman" pitchFamily="34" charset="0"/>
+                <a:ea typeface="Times New Roman" pitchFamily="34" charset="-122"/>
+                <a:cs typeface="Times New Roman" pitchFamily="34" charset="-120"/>
+              </a:rPr>
+              <a:t>Aequitas: an audit toolkit that generates subgroup-wise bias reports directly from model predictions.</a:t>
+            </a:r>
+            <a:endParaRPr lang="en-US" sz="1800" dirty="0"/>
+          </a:p>
+          <a:p>
+            <a:pPr marL="0" indent="0">
+              <a:buNone/>
+            </a:pPr>
+            <a:endParaRPr lang="en-US" sz="1800" dirty="0"/>
+          </a:p>
+          <a:p>
+            <a:pPr marL="0" indent="0">
+              <a:buNone/>
+            </a:pPr>
+            <a:r>
+              <a:rPr lang="en-US" sz="1800" dirty="0">
+                <a:solidFill>
+                  <a:srgbClr val="191919"/>
+                </a:solidFill>
+                <a:latin typeface="Times New Roman" pitchFamily="34" charset="0"/>
+                <a:ea typeface="Times New Roman" pitchFamily="34" charset="-122"/>
+                <a:cs typeface="Times New Roman" pitchFamily="34" charset="-120"/>
+              </a:rPr>
+              <a:t>These tools automate the same subgroup and confusion-matrix analysis performed manually in this lecture.</a:t>
+            </a:r>
+            <a:endParaRPr lang="en-US" sz="1800" dirty="0"/>
+          </a:p>
+        </p:txBody>
+      </p:sp>
+      <p:sp>
+        <p:nvSpPr>
+          <p:cNvPr id="9" name="Text 7"/>
+          <p:cNvSpPr/>
+          <p:nvPr/>
+        </p:nvSpPr>
+        <p:spPr>
+          <a:xfrm>
+            <a:off x="11430000" y="6446520"/>
+            <a:ext cx="365760" cy="182880"/>
+          </a:xfrm>
+          <a:prstGeom prst="rect">
+            <a:avLst/>
+          </a:prstGeom>
+          <a:noFill/>
+          <a:ln/>
+        </p:spPr>
+        <p:txBody>
+          <a:bodyPr wrap="square" lIns="0" tIns="0" rIns="0" bIns="0" rtlCol="0" anchor="ctr"/>
+          <a:lstStyle/>
+          <a:p>
+            <a:pPr marL="0" indent="0" algn="ctr">
+              <a:buNone/>
+            </a:pPr>
+            <a:r>
+              <a:rPr lang="en-US" sz="1200" dirty="0">
+                <a:solidFill>
+                  <a:srgbClr val="595959"/>
+                </a:solidFill>
+                <a:latin typeface="Times New Roman" pitchFamily="34" charset="0"/>
+                <a:ea typeface="Times New Roman" pitchFamily="34" charset="-122"/>
+                <a:cs typeface="Times New Roman" pitchFamily="34" charset="-120"/>
+              </a:rPr>
+              <a:t>10</a:t>
+            </a:r>
+            <a:endParaRPr lang="en-US" sz="1200" dirty="0"/>
+          </a:p>
+        </p:txBody>
+      </p:sp>
+    </p:spTree>
+  </p:cSld>
+  <p:clrMapOvr>
+    <a:masterClrMapping/>
+  </p:clrMapOvr>
+</p:sld>
+</file>
+
+<file path=ppt/slides/slide9.xml><?xml version="1.0" encoding="utf-8"?>
+<p:sld xmlns:a="http://schemas.openxmlformats.org/drawingml/2006/main" xmlns:r="http://schemas.openxmlformats.org/officeDocument/2006/relationships" xmlns:p="http://schemas.openxmlformats.org/presentationml/2006/main">
+  <p:cSld name="Slide 11">
+    <p:bg>
+      <p:bgPr>
+        <a:solidFill>
+          <a:srgbClr val="FFFFFF"/>
+        </a:solidFill>
+        <a:effectLst/>
+      </p:bgPr>
+    </p:bg>
+    <p:spTree>
+      <p:nvGrpSpPr>
+        <p:cNvPr id="1" name=""/>
+        <p:cNvGrpSpPr/>
+        <p:nvPr/>
+      </p:nvGrpSpPr>
+      <p:grpSpPr>
+        <a:xfrm>
+          <a:off x="0" y="0"/>
+          <a:ext cx="0" cy="0"/>
+          <a:chOff x="0" y="0"/>
+          <a:chExt cx="0" cy="0"/>
+        </a:xfrm>
+      </p:grpSpPr>
+      <p:sp>
+        <p:nvSpPr>
+          <p:cNvPr id="2" name="Shape 0"/>
+          <p:cNvSpPr/>
+          <p:nvPr/>
+        </p:nvSpPr>
+        <p:spPr>
+          <a:xfrm>
+            <a:off x="0" y="0"/>
+            <a:ext cx="12191695" cy="502920"/>
+          </a:xfrm>
+          <a:prstGeom prst="rect">
+            <a:avLst/>
+          </a:prstGeom>
+          <a:solidFill>
+            <a:srgbClr val="F8FBFF"/>
+          </a:solidFill>
+          <a:ln w="12700">
+            <a:solidFill>
+              <a:srgbClr val="F8FBFF"/>
+            </a:solidFill>
+            <a:prstDash val="solid"/>
+          </a:ln>
+        </p:spPr>
+        <p:txBody>
+          <a:bodyPr/>
+          <a:lstStyle/>
+          <a:p>
+            <a:endParaRPr lang="en-IN"/>
+          </a:p>
+        </p:txBody>
+      </p:sp>
+      <p:sp>
+        <p:nvSpPr>
+          <p:cNvPr id="3" name="Shape 1"/>
+          <p:cNvSpPr/>
+          <p:nvPr/>
+        </p:nvSpPr>
+        <p:spPr>
+          <a:xfrm>
+            <a:off x="0" y="475488"/>
+            <a:ext cx="12191695" cy="27432"/>
+          </a:xfrm>
+          <a:prstGeom prst="rect">
+            <a:avLst/>
+          </a:prstGeom>
+          <a:solidFill>
+            <a:srgbClr val="2E75B6"/>
+          </a:solidFill>
+          <a:ln w="12700">
+            <a:solidFill>
+              <a:srgbClr val="2E75B6"/>
+            </a:solidFill>
+            <a:prstDash val="solid"/>
+          </a:ln>
+        </p:spPr>
+        <p:txBody>
+          <a:bodyPr/>
+          <a:lstStyle/>
+          <a:p>
+            <a:endParaRPr lang="en-IN"/>
+          </a:p>
+        </p:txBody>
+      </p:sp>
+      <p:sp>
+        <p:nvSpPr>
+          <p:cNvPr id="4" name="Text 2"/>
+          <p:cNvSpPr/>
+          <p:nvPr/>
+        </p:nvSpPr>
+        <p:spPr>
+          <a:xfrm>
+            <a:off x="365760" y="73152"/>
+            <a:ext cx="6400800" cy="274320"/>
+          </a:xfrm>
+          <a:prstGeom prst="rect">
+            <a:avLst/>
+          </a:prstGeom>
+          <a:noFill/>
+          <a:ln/>
+        </p:spPr>
+        <p:txBody>
+          <a:bodyPr wrap="square" lIns="0" tIns="0" rIns="0" bIns="0" rtlCol="0" anchor="ctr"/>
+          <a:lstStyle/>
+          <a:p>
+            <a:pPr marL="0" indent="0">
+              <a:buNone/>
+            </a:pPr>
+            <a:r>
+              <a:rPr lang="en-US" sz="1800" b="1" dirty="0">
+                <a:solidFill>
+                  <a:srgbClr val="1F4E79"/>
+                </a:solidFill>
+                <a:latin typeface="Times New Roman" pitchFamily="34" charset="0"/>
+                <a:ea typeface="Times New Roman" pitchFamily="34" charset="-122"/>
+                <a:cs typeface="Times New Roman" pitchFamily="34" charset="-120"/>
+              </a:rPr>
+              <a:t>TCS349: Responsible and Explainable AI</a:t>
+            </a:r>
+            <a:endParaRPr lang="en-US" sz="1800" dirty="0"/>
+          </a:p>
+        </p:txBody>
+      </p:sp>
+      <p:sp>
+        <p:nvSpPr>
+          <p:cNvPr id="5" name="Text 3"/>
+          <p:cNvSpPr/>
+          <p:nvPr/>
+        </p:nvSpPr>
+        <p:spPr>
+          <a:xfrm>
+            <a:off x="8503920" y="82296"/>
+            <a:ext cx="3200400" cy="274320"/>
+          </a:xfrm>
+          <a:prstGeom prst="rect">
+            <a:avLst/>
+          </a:prstGeom>
+          <a:noFill/>
+          <a:ln/>
+        </p:spPr>
+        <p:txBody>
+          <a:bodyPr wrap="square" lIns="0" tIns="0" rIns="0" bIns="0" rtlCol="0" anchor="ctr"/>
+          <a:lstStyle/>
+          <a:p>
+            <a:pPr marL="0" indent="0" algn="r">
+              <a:buNone/>
+            </a:pPr>
+            <a:r>
+              <a:rPr lang="en-US" sz="1600" b="1" dirty="0">
+                <a:solidFill>
+                  <a:srgbClr val="1F4E79"/>
+                </a:solidFill>
+                <a:latin typeface="Times New Roman" pitchFamily="34" charset="0"/>
+                <a:ea typeface="Times New Roman" pitchFamily="34" charset="-122"/>
+                <a:cs typeface="Times New Roman" pitchFamily="34" charset="-120"/>
+              </a:rPr>
+              <a:t>Unit 1 | Lecture 7</a:t>
+            </a:r>
+            <a:endParaRPr lang="en-US" sz="1600" dirty="0"/>
+          </a:p>
+        </p:txBody>
+      </p:sp>
+      <p:sp>
+        <p:nvSpPr>
+          <p:cNvPr id="6" name="Text 4"/>
+          <p:cNvSpPr/>
+          <p:nvPr/>
+        </p:nvSpPr>
+        <p:spPr>
+          <a:xfrm>
+            <a:off x="502920" y="658368"/>
+            <a:ext cx="11155680" cy="640080"/>
+          </a:xfrm>
+          <a:prstGeom prst="rect">
+            <a:avLst/>
+          </a:prstGeom>
+          <a:noFill/>
+          <a:ln/>
+        </p:spPr>
+        <p:txBody>
+          <a:bodyPr wrap="square" lIns="0" tIns="0" rIns="0" bIns="0" rtlCol="0" anchor="ctr"/>
+          <a:lstStyle/>
+          <a:p>
+            <a:pPr marL="0" indent="0">
+              <a:buNone/>
+            </a:pPr>
+            <a:r>
+              <a:rPr lang="en-US" sz="2400" b="1" dirty="0">
+                <a:solidFill>
+                  <a:srgbClr val="1F4E79"/>
+                </a:solidFill>
+                <a:latin typeface="Times New Roman" pitchFamily="34" charset="0"/>
+                <a:ea typeface="Times New Roman" pitchFamily="34" charset="-122"/>
+                <a:cs typeface="Times New Roman" pitchFamily="34" charset="-120"/>
+              </a:rPr>
+              <a:t>8. From Detecting Bias to Defining Fairness</a:t>
+            </a:r>
+            <a:endParaRPr lang="en-US" sz="2400" dirty="0"/>
+          </a:p>
+        </p:txBody>
+      </p:sp>
+      <p:sp>
+        <p:nvSpPr>
+          <p:cNvPr id="7" name="Text 5"/>
+          <p:cNvSpPr/>
+          <p:nvPr/>
+        </p:nvSpPr>
+        <p:spPr>
+          <a:xfrm>
+            <a:off x="594360" y="1463040"/>
+            <a:ext cx="10972800" cy="4206240"/>
+          </a:xfrm>
+          <a:prstGeom prst="rect">
+            <a:avLst/>
+          </a:prstGeom>
+          <a:noFill/>
+          <a:ln/>
+        </p:spPr>
+        <p:txBody>
+          <a:bodyPr wrap="square" lIns="50800" tIns="50800" rIns="50800" bIns="50800" rtlCol="0" anchor="ctr"/>
+          <a:lstStyle/>
+          <a:p>
+            <a:pPr marL="0" indent="0">
+              <a:buNone/>
+            </a:pPr>
+            <a:r>
+              <a:rPr lang="en-US" sz="1800" dirty="0">
+                <a:solidFill>
+                  <a:srgbClr val="191919"/>
+                </a:solidFill>
+                <a:latin typeface="Times New Roman" pitchFamily="34" charset="0"/>
+                <a:ea typeface="Times New Roman" pitchFamily="34" charset="-122"/>
+                <a:cs typeface="Times New Roman" pitchFamily="34" charset="-120"/>
+              </a:rPr>
+              <a:t>Detecting a numeric gap tells us bias exists - it does not tell us what a "fair" outcome should look like.</a:t>
+            </a:r>
+            <a:endParaRPr lang="en-US" sz="1800" dirty="0"/>
+          </a:p>
+          <a:p>
+            <a:pPr marL="0" indent="0">
+              <a:buNone/>
+            </a:pPr>
+            <a:endParaRPr lang="en-US" sz="1800" dirty="0"/>
+          </a:p>
+          <a:p>
+            <a:pPr marL="0" indent="0">
+              <a:buNone/>
+            </a:pPr>
+            <a:r>
+              <a:rPr lang="en-US" sz="1800" dirty="0">
+                <a:solidFill>
+                  <a:srgbClr val="191919"/>
+                </a:solidFill>
+                <a:latin typeface="Times New Roman" pitchFamily="34" charset="0"/>
+                <a:ea typeface="Times New Roman" pitchFamily="34" charset="-122"/>
+                <a:cs typeface="Times New Roman" pitchFamily="34" charset="-120"/>
+              </a:rPr>
+              <a:t>Fairness in AI is the formal, mathematical attempt to define equitable treatment across individuals and groups.</a:t>
+            </a:r>
+            <a:endParaRPr lang="en-US" sz="1800" dirty="0"/>
+          </a:p>
+          <a:p>
+            <a:pPr marL="0" indent="0">
+              <a:buNone/>
+            </a:pPr>
+            <a:endParaRPr lang="en-US" sz="1800" dirty="0"/>
+          </a:p>
+          <a:p>
+            <a:pPr marL="0" indent="0">
+              <a:buNone/>
+            </a:pPr>
+            <a:r>
+              <a:rPr lang="en-US" sz="1800" dirty="0">
+                <a:solidFill>
+                  <a:srgbClr val="191919"/>
+                </a:solidFill>
+                <a:latin typeface="Times New Roman" pitchFamily="34" charset="0"/>
+                <a:ea typeface="Times New Roman" pitchFamily="34" charset="-122"/>
+                <a:cs typeface="Times New Roman" pitchFamily="34" charset="-120"/>
+              </a:rPr>
+              <a:t>There is no single universal definition of fairness - the appropriate notion depends on context and stakes.</a:t>
+            </a:r>
+            <a:endParaRPr lang="en-US" sz="1800" dirty="0"/>
+          </a:p>
+          <a:p>
+            <a:pPr marL="0" indent="0">
+              <a:buNone/>
+            </a:pPr>
+            <a:endParaRPr lang="en-US" sz="1800" dirty="0"/>
+          </a:p>
+          <a:p>
+            <a:pPr marL="0" indent="0">
+              <a:buNone/>
+            </a:pPr>
+            <a:r>
+              <a:rPr lang="en-US" sz="1800" dirty="0">
+                <a:solidFill>
+                  <a:srgbClr val="191919"/>
+                </a:solidFill>
+                <a:latin typeface="Times New Roman" pitchFamily="34" charset="0"/>
+                <a:ea typeface="Times New Roman" pitchFamily="34" charset="-122"/>
+                <a:cs typeface="Times New Roman" pitchFamily="34" charset="-120"/>
+              </a:rPr>
+              <a:t>The rest of this session introduces the two broad families: group fairness and individual fairness.</a:t>
+            </a:r>
+            <a:endParaRPr lang="en-US" sz="1800" dirty="0"/>
+          </a:p>
+        </p:txBody>
+      </p:sp>
+      <p:sp>
+        <p:nvSpPr>
+          <p:cNvPr id="9" name="Text 7"/>
+          <p:cNvSpPr/>
+          <p:nvPr/>
+        </p:nvSpPr>
+        <p:spPr>
+          <a:xfrm>
+            <a:off x="11430000" y="6446520"/>
+            <a:ext cx="365760" cy="182880"/>
+          </a:xfrm>
+          <a:prstGeom prst="rect">
+            <a:avLst/>
+          </a:prstGeom>
+          <a:noFill/>
+          <a:ln/>
+        </p:spPr>
+        <p:txBody>
+          <a:bodyPr wrap="square" lIns="0" tIns="0" rIns="0" bIns="0" rtlCol="0" anchor="ctr"/>
+          <a:lstStyle/>
+          <a:p>
+            <a:pPr marL="0" indent="0" algn="ctr">
+              <a:buNone/>
+            </a:pPr>
+            <a:r>
+              <a:rPr lang="en-US" sz="1200" dirty="0">
+                <a:solidFill>
+                  <a:srgbClr val="595959"/>
+                </a:solidFill>
+                <a:latin typeface="Times New Roman" pitchFamily="34" charset="0"/>
+                <a:ea typeface="Times New Roman" pitchFamily="34" charset="-122"/>
+                <a:cs typeface="Times New Roman" pitchFamily="34" charset="-120"/>
+              </a:rPr>
+              <a:t>11</a:t>
             </a:r>
             <a:endParaRPr lang="en-US" sz="1200" dirty="0"/>
           </a:p>

</xml_diff>